<commit_message>
Contrast sideways and trending continuation states
</commit_message>
<xml_diff>
--- a/operator_hypothesis_lab/presentations/return_geometry_daily_continuation_microscope.pptx
+++ b/operator_hypothesis_lab/presentations/return_geometry_daily_continuation_microscope.pptx
@@ -2,21 +2,27 @@
 <file path=ppt/presentation.xml><?xml version="1.0" encoding="utf-8"?>
 <p:presentation xmlns:p="http://schemas.openxmlformats.org/presentationml/2006/main">
   <p:sldMasterIdLst>
-    <p:sldMasterId xmlns:r="http://schemas.openxmlformats.org/officeDocument/2006/relationships" id="2147483648" r:id="Rcbba2aee34114d29"/>
+    <p:sldMasterId xmlns:r="http://schemas.openxmlformats.org/officeDocument/2006/relationships" id="2147483648" r:id="R0097c60ca9884520"/>
   </p:sldMasterIdLst>
   <p:notesMasterIdLst>
-    <p:notesMasterId xmlns:r="http://schemas.openxmlformats.org/officeDocument/2006/relationships" r:id="R35f75271a3e64ee4"/>
+    <p:notesMasterId xmlns:r="http://schemas.openxmlformats.org/officeDocument/2006/relationships" r:id="Ra6cfa17bd13c477a"/>
   </p:notesMasterIdLst>
   <p:sldIdLst>
-    <p:sldId xmlns:r="http://schemas.openxmlformats.org/officeDocument/2006/relationships" id="256" r:id="Raca35ff9f72d4275"/>
-    <p:sldId xmlns:r="http://schemas.openxmlformats.org/officeDocument/2006/relationships" id="257" r:id="R926c09c35045415e"/>
-    <p:sldId xmlns:r="http://schemas.openxmlformats.org/officeDocument/2006/relationships" id="258" r:id="R7d4f5ce121bf41f1"/>
-    <p:sldId xmlns:r="http://schemas.openxmlformats.org/officeDocument/2006/relationships" id="259" r:id="R3c625c8a9a44408f"/>
-    <p:sldId xmlns:r="http://schemas.openxmlformats.org/officeDocument/2006/relationships" id="260" r:id="R5c25987723914910"/>
-    <p:sldId xmlns:r="http://schemas.openxmlformats.org/officeDocument/2006/relationships" id="261" r:id="R942749c4226e471d"/>
-    <p:sldId xmlns:r="http://schemas.openxmlformats.org/officeDocument/2006/relationships" id="262" r:id="Rbbbd283063e846b5"/>
-    <p:sldId xmlns:r="http://schemas.openxmlformats.org/officeDocument/2006/relationships" id="263" r:id="Rc870a23bc6844430"/>
-    <p:sldId xmlns:r="http://schemas.openxmlformats.org/officeDocument/2006/relationships" id="264" r:id="R0b59ef5af3a646fc"/>
+    <p:sldId xmlns:r="http://schemas.openxmlformats.org/officeDocument/2006/relationships" id="256" r:id="R7f6041ace4974ec6"/>
+    <p:sldId xmlns:r="http://schemas.openxmlformats.org/officeDocument/2006/relationships" id="257" r:id="R5798945275e045d6"/>
+    <p:sldId xmlns:r="http://schemas.openxmlformats.org/officeDocument/2006/relationships" id="258" r:id="R151aed5e11834ded"/>
+    <p:sldId xmlns:r="http://schemas.openxmlformats.org/officeDocument/2006/relationships" id="259" r:id="R50e2dc2b82804a5c"/>
+    <p:sldId xmlns:r="http://schemas.openxmlformats.org/officeDocument/2006/relationships" id="260" r:id="Rad401365f5744ae2"/>
+    <p:sldId xmlns:r="http://schemas.openxmlformats.org/officeDocument/2006/relationships" id="261" r:id="R01f9002166344e69"/>
+    <p:sldId xmlns:r="http://schemas.openxmlformats.org/officeDocument/2006/relationships" id="262" r:id="Ra602d09fccf54ae7"/>
+    <p:sldId xmlns:r="http://schemas.openxmlformats.org/officeDocument/2006/relationships" id="263" r:id="Rd0a0f623f2f04281"/>
+    <p:sldId xmlns:r="http://schemas.openxmlformats.org/officeDocument/2006/relationships" id="264" r:id="Rbd935ccf41584057"/>
+    <p:sldId xmlns:r="http://schemas.openxmlformats.org/officeDocument/2006/relationships" id="265" r:id="R113353cfa457459d"/>
+    <p:sldId xmlns:r="http://schemas.openxmlformats.org/officeDocument/2006/relationships" id="266" r:id="R779b236355fc47da"/>
+    <p:sldId xmlns:r="http://schemas.openxmlformats.org/officeDocument/2006/relationships" id="267" r:id="Rc12dc436bc114d3b"/>
+    <p:sldId xmlns:r="http://schemas.openxmlformats.org/officeDocument/2006/relationships" id="268" r:id="R142e6b1e53074be2"/>
+    <p:sldId xmlns:r="http://schemas.openxmlformats.org/officeDocument/2006/relationships" id="269" r:id="R7a062c592c6a4048"/>
+    <p:sldId xmlns:r="http://schemas.openxmlformats.org/officeDocument/2006/relationships" id="270" r:id="Rf172dc5ea2114b28"/>
   </p:sldIdLst>
   <p:sldSz cx="12192000" cy="6858000"/>
   <p:notesSz cx="6858000" cy="9144000"/>
@@ -510,6 +516,581 @@
 </p:notes>
 </file>
 
+<file path=ppt/notesSlides/notesSlide10.xml><?xml version="1.0" encoding="utf-8"?>
+<p:notes xmlns:p="http://schemas.openxmlformats.org/presentationml/2006/main">
+  <p:cSld>
+    <p:spTree>
+      <p:nvGrpSpPr>
+        <p:cNvPr id="1" name=""/>
+        <p:cNvGrpSpPr/>
+        <p:nvPr/>
+      </p:nvGrpSpPr>
+      <p:grpSpPr>
+        <a:xfrm xmlns:a="http://schemas.openxmlformats.org/drawingml/2006/main"/>
+      </p:grpSpPr>
+      <p:sp>
+        <p:nvSpPr>
+          <p:cNvPr id="2" name="Slide Image Placeholder 1"/>
+          <p:cNvSpPr>
+            <a:spLocks xmlns:a="http://schemas.openxmlformats.org/drawingml/2006/main" noGrp="1"/>
+          </p:cNvSpPr>
+          <p:nvPr>
+            <p:ph type="sldImg" idx="0"/>
+          </p:nvPr>
+        </p:nvSpPr>
+        <p:spPr/>
+      </p:sp>
+      <p:sp>
+        <p:nvSpPr>
+          <p:cNvPr id="3" name="Notes Placeholder 2"/>
+          <p:cNvSpPr>
+            <a:spLocks xmlns:a="http://schemas.openxmlformats.org/drawingml/2006/main" noGrp="1"/>
+          </p:cNvSpPr>
+          <p:nvPr>
+            <p:ph type="body" idx="1"/>
+          </p:nvPr>
+        </p:nvSpPr>
+        <p:spPr/>
+        <p:txBody>
+          <a:bodyPr xmlns:a="http://schemas.openxmlformats.org/drawingml/2006/main"/>
+          <a:lstStyle xmlns:a="http://schemas.openxmlformats.org/drawingml/2006/main"/>
+          <a:p xmlns:a="http://schemas.openxmlformats.org/drawingml/2006/main">
+            <a:r>
+              <a:t>The operator selected the direct ER20-sideways versus ER20-trending comparison for fuller context. This section re-expresses the already-computed 2018-2023 atlas; it does not recompute returns, select a horizon, or test a trading rule.</a:t>
+            </a:r>
+          </a:p>
+          <a:p xmlns:a="http://schemas.openxmlformats.org/drawingml/2006/main">
+            <a:r>
+              <a:t/>
+            </a:r>
+          </a:p>
+          <a:p xmlns:a="http://schemas.openxmlformats.org/drawingml/2006/main">
+            <a:r>
+              <a:t>[Sources]</a:t>
+            </a:r>
+          </a:p>
+          <a:p xmlns:a="http://schemas.openxmlformats.org/drawingml/2006/main">
+            <a:r>
+              <a:t>- operator_hypothesis_lab/docs/RETURN_GEOMETRY_DAILY_CONTINUATION_MICROSCOPE_2018_2023.md</a:t>
+            </a:r>
+          </a:p>
+          <a:p xmlns:a="http://schemas.openxmlformats.org/drawingml/2006/main">
+            <a:r>
+              <a:t>- runs/research_workbench/operator_hypothesis_lab/return_geometry_continuation_state_contrast_20260828/run_spec.csv</a:t>
+            </a:r>
+          </a:p>
+          <a:p xmlns:a="http://schemas.openxmlformats.org/drawingml/2006/main">
+            <a:r>
+              <a:t>[/Sources]</a:t>
+            </a:r>
+          </a:p>
+        </p:txBody>
+      </p:sp>
+      <p:sp>
+        <p:nvSpPr>
+          <p:cNvPr id="4" name="Slide Number Placeholder 3"/>
+          <p:cNvSpPr>
+            <a:spLocks xmlns:a="http://schemas.openxmlformats.org/drawingml/2006/main" noGrp="1"/>
+          </p:cNvSpPr>
+          <p:nvPr>
+            <p:ph type="sldNum" idx="5"/>
+          </p:nvPr>
+        </p:nvSpPr>
+        <p:spPr/>
+        <p:txBody>
+          <a:bodyPr xmlns:a="http://schemas.openxmlformats.org/drawingml/2006/main"/>
+          <a:lstStyle xmlns:a="http://schemas.openxmlformats.org/drawingml/2006/main"/>
+          <a:p xmlns:a="http://schemas.openxmlformats.org/drawingml/2006/main"/>
+        </p:txBody>
+      </p:sp>
+    </p:spTree>
+  </p:cSld>
+  <p:clrMapOvr>
+    <a:masterClrMapping xmlns:a="http://schemas.openxmlformats.org/drawingml/2006/main"/>
+  </p:clrMapOvr>
+</p:notes>
+</file>
+
+<file path=ppt/notesSlides/notesSlide11.xml><?xml version="1.0" encoding="utf-8"?>
+<p:notes xmlns:p="http://schemas.openxmlformats.org/presentationml/2006/main">
+  <p:cSld>
+    <p:spTree>
+      <p:nvGrpSpPr>
+        <p:cNvPr id="1" name=""/>
+        <p:cNvGrpSpPr/>
+        <p:nvPr/>
+      </p:nvGrpSpPr>
+      <p:grpSpPr>
+        <a:xfrm xmlns:a="http://schemas.openxmlformats.org/drawingml/2006/main"/>
+      </p:grpSpPr>
+      <p:sp>
+        <p:nvSpPr>
+          <p:cNvPr id="2" name="Slide Image Placeholder 1"/>
+          <p:cNvSpPr>
+            <a:spLocks xmlns:a="http://schemas.openxmlformats.org/drawingml/2006/main" noGrp="1"/>
+          </p:cNvSpPr>
+          <p:nvPr>
+            <p:ph type="sldImg" idx="0"/>
+          </p:nvPr>
+        </p:nvSpPr>
+        <p:spPr/>
+      </p:sp>
+      <p:sp>
+        <p:nvSpPr>
+          <p:cNvPr id="3" name="Notes Placeholder 2"/>
+          <p:cNvSpPr>
+            <a:spLocks xmlns:a="http://schemas.openxmlformats.org/drawingml/2006/main" noGrp="1"/>
+          </p:cNvSpPr>
+          <p:nvPr>
+            <p:ph type="body" idx="1"/>
+          </p:nvPr>
+        </p:nvSpPr>
+        <p:spPr/>
+        <p:txBody>
+          <a:bodyPr xmlns:a="http://schemas.openxmlformats.org/drawingml/2006/main"/>
+          <a:lstStyle xmlns:a="http://schemas.openxmlformats.org/drawingml/2006/main"/>
+          <a:p xmlns:a="http://schemas.openxmlformats.org/drawingml/2006/main">
+            <a:r>
+              <a:t>Across all 225 cells, the median equal-sector positive-prior correlation is +0.027 in ER20-sideways and -0.028 in ER20-trending. Both use the identical asset core, horizon vocabulary, and causal state timing.</a:t>
+            </a:r>
+          </a:p>
+          <a:p xmlns:a="http://schemas.openxmlformats.org/drawingml/2006/main">
+            <a:r>
+              <a:t/>
+            </a:r>
+          </a:p>
+          <a:p xmlns:a="http://schemas.openxmlformats.org/drawingml/2006/main">
+            <a:r>
+              <a:t>[Sources]</a:t>
+            </a:r>
+          </a:p>
+          <a:p xmlns:a="http://schemas.openxmlformats.org/drawingml/2006/main">
+            <a:r>
+              <a:t>- runs/research_workbench/operator_hypothesis_lab/return_geometry_continuation_state_contrast_20260828/contrast_summary.csv</a:t>
+            </a:r>
+          </a:p>
+          <a:p xmlns:a="http://schemas.openxmlformats.org/drawingml/2006/main">
+            <a:r>
+              <a:t>- runs/research_workbench/operator_hypothesis_lab/return_geometry_continuation_state_contrast_20260828/visuals/sideways_vs_trending_positive_branch_heatmaps.png</a:t>
+            </a:r>
+          </a:p>
+          <a:p xmlns:a="http://schemas.openxmlformats.org/drawingml/2006/main">
+            <a:r>
+              <a:t>[/Sources]</a:t>
+            </a:r>
+          </a:p>
+        </p:txBody>
+      </p:sp>
+      <p:sp>
+        <p:nvSpPr>
+          <p:cNvPr id="4" name="Slide Number Placeholder 3"/>
+          <p:cNvSpPr>
+            <a:spLocks xmlns:a="http://schemas.openxmlformats.org/drawingml/2006/main" noGrp="1"/>
+          </p:cNvSpPr>
+          <p:nvPr>
+            <p:ph type="sldNum" idx="5"/>
+          </p:nvPr>
+        </p:nvSpPr>
+        <p:spPr/>
+        <p:txBody>
+          <a:bodyPr xmlns:a="http://schemas.openxmlformats.org/drawingml/2006/main"/>
+          <a:lstStyle xmlns:a="http://schemas.openxmlformats.org/drawingml/2006/main"/>
+          <a:p xmlns:a="http://schemas.openxmlformats.org/drawingml/2006/main"/>
+        </p:txBody>
+      </p:sp>
+    </p:spTree>
+  </p:cSld>
+  <p:clrMapOvr>
+    <a:masterClrMapping xmlns:a="http://schemas.openxmlformats.org/drawingml/2006/main"/>
+  </p:clrMapOvr>
+</p:notes>
+</file>
+
+<file path=ppt/notesSlides/notesSlide12.xml><?xml version="1.0" encoding="utf-8"?>
+<p:notes xmlns:p="http://schemas.openxmlformats.org/presentationml/2006/main">
+  <p:cSld>
+    <p:spTree>
+      <p:nvGrpSpPr>
+        <p:cNvPr id="1" name=""/>
+        <p:cNvGrpSpPr/>
+        <p:nvPr/>
+      </p:nvGrpSpPr>
+      <p:grpSpPr>
+        <a:xfrm xmlns:a="http://schemas.openxmlformats.org/drawingml/2006/main"/>
+      </p:grpSpPr>
+      <p:sp>
+        <p:nvSpPr>
+          <p:cNvPr id="2" name="Slide Image Placeholder 1"/>
+          <p:cNvSpPr>
+            <a:spLocks xmlns:a="http://schemas.openxmlformats.org/drawingml/2006/main" noGrp="1"/>
+          </p:cNvSpPr>
+          <p:nvPr>
+            <p:ph type="sldImg" idx="0"/>
+          </p:nvPr>
+        </p:nvSpPr>
+        <p:spPr/>
+      </p:sp>
+      <p:sp>
+        <p:nvSpPr>
+          <p:cNvPr id="3" name="Notes Placeholder 2"/>
+          <p:cNvSpPr>
+            <a:spLocks xmlns:a="http://schemas.openxmlformats.org/drawingml/2006/main" noGrp="1"/>
+          </p:cNvSpPr>
+          <p:nvPr>
+            <p:ph type="body" idx="1"/>
+          </p:nvPr>
+        </p:nvSpPr>
+        <p:spPr/>
+        <p:txBody>
+          <a:bodyPr xmlns:a="http://schemas.openxmlformats.org/drawingml/2006/main"/>
+          <a:lstStyle xmlns:a="http://schemas.openxmlformats.org/drawingml/2006/main"/>
+          <a:p xmlns:a="http://schemas.openxmlformats.org/drawingml/2006/main">
+            <a:r>
+              <a:t>Each asset is paired inside the same prior/following horizon cell before sector aggregation. The all-surface median paired contrast is +0.048, and 209 of 225 cells are positive. The contrast is a difference in correlations, not a return or spread trade.</a:t>
+            </a:r>
+          </a:p>
+          <a:p xmlns:a="http://schemas.openxmlformats.org/drawingml/2006/main">
+            <a:r>
+              <a:t/>
+            </a:r>
+          </a:p>
+          <a:p xmlns:a="http://schemas.openxmlformats.org/drawingml/2006/main">
+            <a:r>
+              <a:t>[Sources]</a:t>
+            </a:r>
+          </a:p>
+          <a:p xmlns:a="http://schemas.openxmlformats.org/drawingml/2006/main">
+            <a:r>
+              <a:t>- runs/research_workbench/operator_hypothesis_lab/return_geometry_continuation_state_contrast_20260828/equal_sector_paired_cell_summary.csv</a:t>
+            </a:r>
+          </a:p>
+          <a:p xmlns:a="http://schemas.openxmlformats.org/drawingml/2006/main">
+            <a:r>
+              <a:t>- runs/research_workbench/operator_hypothesis_lab/return_geometry_continuation_state_contrast_20260828/visuals/sideways_minus_trending_paired_heatmap.png</a:t>
+            </a:r>
+          </a:p>
+          <a:p xmlns:a="http://schemas.openxmlformats.org/drawingml/2006/main">
+            <a:r>
+              <a:t>[/Sources]</a:t>
+            </a:r>
+          </a:p>
+        </p:txBody>
+      </p:sp>
+      <p:sp>
+        <p:nvSpPr>
+          <p:cNvPr id="4" name="Slide Number Placeholder 3"/>
+          <p:cNvSpPr>
+            <a:spLocks xmlns:a="http://schemas.openxmlformats.org/drawingml/2006/main" noGrp="1"/>
+          </p:cNvSpPr>
+          <p:nvPr>
+            <p:ph type="sldNum" idx="5"/>
+          </p:nvPr>
+        </p:nvSpPr>
+        <p:spPr/>
+        <p:txBody>
+          <a:bodyPr xmlns:a="http://schemas.openxmlformats.org/drawingml/2006/main"/>
+          <a:lstStyle xmlns:a="http://schemas.openxmlformats.org/drawingml/2006/main"/>
+          <a:p xmlns:a="http://schemas.openxmlformats.org/drawingml/2006/main"/>
+        </p:txBody>
+      </p:sp>
+    </p:spTree>
+  </p:cSld>
+  <p:clrMapOvr>
+    <a:masterClrMapping xmlns:a="http://schemas.openxmlformats.org/drawingml/2006/main"/>
+  </p:clrMapOvr>
+</p:notes>
+</file>
+
+<file path=ppt/notesSlides/notesSlide13.xml><?xml version="1.0" encoding="utf-8"?>
+<p:notes xmlns:p="http://schemas.openxmlformats.org/presentationml/2006/main">
+  <p:cSld>
+    <p:spTree>
+      <p:nvGrpSpPr>
+        <p:cNvPr id="1" name=""/>
+        <p:cNvGrpSpPr/>
+        <p:nvPr/>
+      </p:nvGrpSpPr>
+      <p:grpSpPr>
+        <a:xfrm xmlns:a="http://schemas.openxmlformats.org/drawingml/2006/main"/>
+      </p:grpSpPr>
+      <p:sp>
+        <p:nvSpPr>
+          <p:cNvPr id="2" name="Slide Image Placeholder 1"/>
+          <p:cNvSpPr>
+            <a:spLocks xmlns:a="http://schemas.openxmlformats.org/drawingml/2006/main" noGrp="1"/>
+          </p:cNvSpPr>
+          <p:nvPr>
+            <p:ph type="sldImg" idx="0"/>
+          </p:nvPr>
+        </p:nvSpPr>
+        <p:spPr/>
+      </p:sp>
+      <p:sp>
+        <p:nvSpPr>
+          <p:cNvPr id="3" name="Notes Placeholder 2"/>
+          <p:cNvSpPr>
+            <a:spLocks xmlns:a="http://schemas.openxmlformats.org/drawingml/2006/main" noGrp="1"/>
+          </p:cNvSpPr>
+          <p:nvPr>
+            <p:ph type="body" idx="1"/>
+          </p:nvPr>
+        </p:nvSpPr>
+        <p:spPr/>
+        <p:txBody>
+          <a:bodyPr xmlns:a="http://schemas.openxmlformats.org/drawingml/2006/main"/>
+          <a:lstStyle xmlns:a="http://schemas.openxmlformats.org/drawingml/2006/main"/>
+          <a:p xmlns:a="http://schemas.openxmlformats.org/drawingml/2006/main">
+            <a:r>
+              <a:t>Every core sector has a positive median paired contrast across its 225-cell surface. The median contrast ranges from about +0.020 in Utilities to +0.077 in Health Care. Positive-cell breadth ranges from 62.2 to 85.8 percent, so the shape is broad but not uniform.</a:t>
+            </a:r>
+          </a:p>
+          <a:p xmlns:a="http://schemas.openxmlformats.org/drawingml/2006/main">
+            <a:r>
+              <a:t/>
+            </a:r>
+          </a:p>
+          <a:p xmlns:a="http://schemas.openxmlformats.org/drawingml/2006/main">
+            <a:r>
+              <a:t>[Sources]</a:t>
+            </a:r>
+          </a:p>
+          <a:p xmlns:a="http://schemas.openxmlformats.org/drawingml/2006/main">
+            <a:r>
+              <a:t>- runs/research_workbench/operator_hypothesis_lab/return_geometry_continuation_state_contrast_20260828/sector_surface_summary.csv</a:t>
+            </a:r>
+          </a:p>
+          <a:p xmlns:a="http://schemas.openxmlformats.org/drawingml/2006/main">
+            <a:r>
+              <a:t>- runs/research_workbench/operator_hypothesis_lab/return_geometry_continuation_state_contrast_20260828/visuals/sideways_advantage_by_sector.png</a:t>
+            </a:r>
+          </a:p>
+          <a:p xmlns:a="http://schemas.openxmlformats.org/drawingml/2006/main">
+            <a:r>
+              <a:t>[/Sources]</a:t>
+            </a:r>
+          </a:p>
+        </p:txBody>
+      </p:sp>
+      <p:sp>
+        <p:nvSpPr>
+          <p:cNvPr id="4" name="Slide Number Placeholder 3"/>
+          <p:cNvSpPr>
+            <a:spLocks xmlns:a="http://schemas.openxmlformats.org/drawingml/2006/main" noGrp="1"/>
+          </p:cNvSpPr>
+          <p:nvPr>
+            <p:ph type="sldNum" idx="5"/>
+          </p:nvPr>
+        </p:nvSpPr>
+        <p:spPr/>
+        <p:txBody>
+          <a:bodyPr xmlns:a="http://schemas.openxmlformats.org/drawingml/2006/main"/>
+          <a:lstStyle xmlns:a="http://schemas.openxmlformats.org/drawingml/2006/main"/>
+          <a:p xmlns:a="http://schemas.openxmlformats.org/drawingml/2006/main"/>
+        </p:txBody>
+      </p:sp>
+    </p:spTree>
+  </p:cSld>
+  <p:clrMapOvr>
+    <a:masterClrMapping xmlns:a="http://schemas.openxmlformats.org/drawingml/2006/main"/>
+  </p:clrMapOvr>
+</p:notes>
+</file>
+
+<file path=ppt/notesSlides/notesSlide14.xml><?xml version="1.0" encoding="utf-8"?>
+<p:notes xmlns:p="http://schemas.openxmlformats.org/presentationml/2006/main">
+  <p:cSld>
+    <p:spTree>
+      <p:nvGrpSpPr>
+        <p:cNvPr id="1" name=""/>
+        <p:cNvGrpSpPr/>
+        <p:nvPr/>
+      </p:nvGrpSpPr>
+      <p:grpSpPr>
+        <a:xfrm xmlns:a="http://schemas.openxmlformats.org/drawingml/2006/main"/>
+      </p:grpSpPr>
+      <p:sp>
+        <p:nvSpPr>
+          <p:cNvPr id="2" name="Slide Image Placeholder 1"/>
+          <p:cNvSpPr>
+            <a:spLocks xmlns:a="http://schemas.openxmlformats.org/drawingml/2006/main" noGrp="1"/>
+          </p:cNvSpPr>
+          <p:nvPr>
+            <p:ph type="sldImg" idx="0"/>
+          </p:nvPr>
+        </p:nvSpPr>
+        <p:spPr/>
+      </p:sp>
+      <p:sp>
+        <p:nvSpPr>
+          <p:cNvPr id="3" name="Notes Placeholder 2"/>
+          <p:cNvSpPr>
+            <a:spLocks xmlns:a="http://schemas.openxmlformats.org/drawingml/2006/main" noGrp="1"/>
+          </p:cNvSpPr>
+          <p:nvPr>
+            <p:ph type="body" idx="1"/>
+          </p:nvPr>
+        </p:nvSpPr>
+        <p:spPr/>
+        <p:txBody>
+          <a:bodyPr xmlns:a="http://schemas.openxmlformats.org/drawingml/2006/main"/>
+          <a:lstStyle xmlns:a="http://schemas.openxmlformats.org/drawingml/2006/main"/>
+          <a:p xmlns:a="http://schemas.openxmlformats.org/drawingml/2006/main">
+            <a:r>
+              <a:t>The diagonal is mostly positive but not monotone. The paired contrast is negative at 1-to-1 and 100-to-100, while its largest equal-horizon value occurs at 10-to-10. Across the full grid, 16 cells do not favor sideways; exceptions cluster at micro horizons and several 20-prior / long-forward combinations. These are context, not permission to choose 10-to-10.</a:t>
+            </a:r>
+          </a:p>
+          <a:p xmlns:a="http://schemas.openxmlformats.org/drawingml/2006/main">
+            <a:r>
+              <a:t/>
+            </a:r>
+          </a:p>
+          <a:p xmlns:a="http://schemas.openxmlformats.org/drawingml/2006/main">
+            <a:r>
+              <a:t>[Sources]</a:t>
+            </a:r>
+          </a:p>
+          <a:p xmlns:a="http://schemas.openxmlformats.org/drawingml/2006/main">
+            <a:r>
+              <a:t>- runs/research_workbench/operator_hypothesis_lab/return_geometry_continuation_state_contrast_20260828/equal_sector_paired_diagonal.csv</a:t>
+            </a:r>
+          </a:p>
+          <a:p xmlns:a="http://schemas.openxmlformats.org/drawingml/2006/main">
+            <a:r>
+              <a:t>- runs/research_workbench/operator_hypothesis_lab/return_geometry_continuation_state_contrast_20260828/visuals/sideways_vs_trending_diagonal.png</a:t>
+            </a:r>
+          </a:p>
+          <a:p xmlns:a="http://schemas.openxmlformats.org/drawingml/2006/main">
+            <a:r>
+              <a:t>[/Sources]</a:t>
+            </a:r>
+          </a:p>
+        </p:txBody>
+      </p:sp>
+      <p:sp>
+        <p:nvSpPr>
+          <p:cNvPr id="4" name="Slide Number Placeholder 3"/>
+          <p:cNvSpPr>
+            <a:spLocks xmlns:a="http://schemas.openxmlformats.org/drawingml/2006/main" noGrp="1"/>
+          </p:cNvSpPr>
+          <p:nvPr>
+            <p:ph type="sldNum" idx="5"/>
+          </p:nvPr>
+        </p:nvSpPr>
+        <p:spPr/>
+        <p:txBody>
+          <a:bodyPr xmlns:a="http://schemas.openxmlformats.org/drawingml/2006/main"/>
+          <a:lstStyle xmlns:a="http://schemas.openxmlformats.org/drawingml/2006/main"/>
+          <a:p xmlns:a="http://schemas.openxmlformats.org/drawingml/2006/main"/>
+        </p:txBody>
+      </p:sp>
+    </p:spTree>
+  </p:cSld>
+  <p:clrMapOvr>
+    <a:masterClrMapping xmlns:a="http://schemas.openxmlformats.org/drawingml/2006/main"/>
+  </p:clrMapOvr>
+</p:notes>
+</file>
+
+<file path=ppt/notesSlides/notesSlide15.xml><?xml version="1.0" encoding="utf-8"?>
+<p:notes xmlns:p="http://schemas.openxmlformats.org/presentationml/2006/main">
+  <p:cSld>
+    <p:spTree>
+      <p:nvGrpSpPr>
+        <p:cNvPr id="1" name=""/>
+        <p:cNvGrpSpPr/>
+        <p:nvPr/>
+      </p:nvGrpSpPr>
+      <p:grpSpPr>
+        <a:xfrm xmlns:a="http://schemas.openxmlformats.org/drawingml/2006/main"/>
+      </p:grpSpPr>
+      <p:sp>
+        <p:nvSpPr>
+          <p:cNvPr id="2" name="Slide Image Placeholder 1"/>
+          <p:cNvSpPr>
+            <a:spLocks xmlns:a="http://schemas.openxmlformats.org/drawingml/2006/main" noGrp="1"/>
+          </p:cNvSpPr>
+          <p:nvPr>
+            <p:ph type="sldImg" idx="0"/>
+          </p:nvPr>
+        </p:nvSpPr>
+        <p:spPr/>
+      </p:sp>
+      <p:sp>
+        <p:nvSpPr>
+          <p:cNvPr id="3" name="Notes Placeholder 2"/>
+          <p:cNvSpPr>
+            <a:spLocks xmlns:a="http://schemas.openxmlformats.org/drawingml/2006/main" noGrp="1"/>
+          </p:cNvSpPr>
+          <p:nvPr>
+            <p:ph type="body" idx="1"/>
+          </p:nvPr>
+        </p:nvSpPr>
+        <p:spPr/>
+        <p:txBody>
+          <a:bodyPr xmlns:a="http://schemas.openxmlformats.org/drawingml/2006/main"/>
+          <a:lstStyle xmlns:a="http://schemas.openxmlformats.org/drawingml/2006/main"/>
+          <a:p xmlns:a="http://schemas.openxmlformats.org/drawingml/2006/main">
+            <a:r>
+              <a:t>The approved comparison strengthened the behavioral description: sideways and trending are not merely different-looking heatmaps; their paired difference is positive across most cells and every sector's median surface. The magnitude remains small and the same research history discovered the contrast, so the lane stops before horizon choice or trading translation.</a:t>
+            </a:r>
+          </a:p>
+          <a:p xmlns:a="http://schemas.openxmlformats.org/drawingml/2006/main">
+            <a:r>
+              <a:t/>
+            </a:r>
+          </a:p>
+          <a:p xmlns:a="http://schemas.openxmlformats.org/drawingml/2006/main">
+            <a:r>
+              <a:t>[Sources]</a:t>
+            </a:r>
+          </a:p>
+          <a:p xmlns:a="http://schemas.openxmlformats.org/drawingml/2006/main">
+            <a:r>
+              <a:t>- runs/research_workbench/operator_hypothesis_lab/return_geometry_continuation_state_contrast_20260828/report.md</a:t>
+            </a:r>
+          </a:p>
+          <a:p xmlns:a="http://schemas.openxmlformats.org/drawingml/2006/main">
+            <a:r>
+              <a:t>- runs/research_workbench/operator_hypothesis_lab/return_geometry_continuation_state_contrast_20260828/contrast_summary.csv</a:t>
+            </a:r>
+          </a:p>
+          <a:p xmlns:a="http://schemas.openxmlformats.org/drawingml/2006/main">
+            <a:r>
+              <a:t>- operator_hypothesis_lab/docs/RETURN_GEOMETRY_DAILY_CONTINUATION_MICROSCOPE_2018_2023.md</a:t>
+            </a:r>
+          </a:p>
+          <a:p xmlns:a="http://schemas.openxmlformats.org/drawingml/2006/main">
+            <a:r>
+              <a:t>[/Sources]</a:t>
+            </a:r>
+          </a:p>
+        </p:txBody>
+      </p:sp>
+      <p:sp>
+        <p:nvSpPr>
+          <p:cNvPr id="4" name="Slide Number Placeholder 3"/>
+          <p:cNvSpPr>
+            <a:spLocks xmlns:a="http://schemas.openxmlformats.org/drawingml/2006/main" noGrp="1"/>
+          </p:cNvSpPr>
+          <p:nvPr>
+            <p:ph type="sldNum" idx="5"/>
+          </p:nvPr>
+        </p:nvSpPr>
+        <p:spPr/>
+        <p:txBody>
+          <a:bodyPr xmlns:a="http://schemas.openxmlformats.org/drawingml/2006/main"/>
+          <a:lstStyle xmlns:a="http://schemas.openxmlformats.org/drawingml/2006/main"/>
+          <a:p xmlns:a="http://schemas.openxmlformats.org/drawingml/2006/main"/>
+        </p:txBody>
+      </p:sp>
+    </p:spTree>
+  </p:cSld>
+  <p:clrMapOvr>
+    <a:masterClrMapping xmlns:a="http://schemas.openxmlformats.org/drawingml/2006/main"/>
+  </p:clrMapOvr>
+</p:notes>
+</file>
+
 <file path=ppt/notesSlides/notesSlide2.xml><?xml version="1.0" encoding="utf-8"?>
 <p:notes xmlns:p="http://schemas.openxmlformats.org/presentationml/2006/main">
   <p:cSld>
@@ -1313,7 +1894,7 @@
   </p:cSld>
   <p:clrMap bg1="lt1" tx1="dk1" bg2="lt2" tx2="dk2" accent1="accent1" accent2="accent2" accent3="accent3" accent4="accent4" accent5="accent5" accent6="accent6" hlink="hlink" folHlink="folHlink"/>
   <p:sldLayoutIdLst>
-    <p:sldLayoutId xmlns:r="http://schemas.openxmlformats.org/officeDocument/2006/relationships" id="2147483649" r:id="R6df414efe88c48e8"/>
+    <p:sldLayoutId xmlns:r="http://schemas.openxmlformats.org/officeDocument/2006/relationships" id="2147483649" r:id="R646df8c041414fa7"/>
   </p:sldLayoutIdLst>
   <p:txStyles>
     <p:titleStyle>
@@ -2157,6 +2738,2781 @@
 </p:sld>
 </file>
 
+<file path=ppt/slides/slide10.xml><?xml version="1.0" encoding="utf-8"?>
+<p:sld xmlns:p="http://schemas.openxmlformats.org/presentationml/2006/main">
+  <p:cSld>
+    <p:bg>
+      <p:bgPr>
+        <a:solidFill xmlns:a="http://schemas.openxmlformats.org/drawingml/2006/main">
+          <a:srgbClr val="FFFFFF"/>
+        </a:solidFill>
+      </p:bgPr>
+    </p:bg>
+    <p:spTree>
+      <p:nvGrpSpPr>
+        <p:cNvPr id="1" name=""/>
+        <p:cNvGrpSpPr/>
+        <p:nvPr/>
+      </p:nvGrpSpPr>
+      <p:grpSpPr>
+        <a:xfrm xmlns:a="http://schemas.openxmlformats.org/drawingml/2006/main"/>
+      </p:grpSpPr>
+      <p:sp>
+        <p:nvSpPr>
+          <p:cNvPr id="7" name="">
+            <a:extLst xmlns:a="http://schemas.openxmlformats.org/drawingml/2006/main">
+              <a:ext uri="{FF2B5EF4-FFF2-40B4-BE49-F238E27FC236}">
+                <a16:creationId xmlns:a16="http://schemas.microsoft.com/office/drawing/2014/main" id="{DB12B881-2D87-4470-A9E2-CA40D710634E}"/>
+              </a:ext>
+            </a:extLst>
+          </p:cNvPr>
+          <p:cNvSpPr>
+            <a:spLocks xmlns:a="http://schemas.openxmlformats.org/drawingml/2006/main" noGrp="1"/>
+          </p:cNvSpPr>
+          <p:nvPr/>
+        </p:nvSpPr>
+        <p:spPr>
+          <a:xfrm xmlns:a="http://schemas.openxmlformats.org/drawingml/2006/main">
+            <a:off x="457200" y="400050"/>
+            <a:ext cx="4000500" cy="266700"/>
+          </a:xfrm>
+          <a:prstGeom xmlns:a="http://schemas.openxmlformats.org/drawingml/2006/main" prst="rect">
+            <a:avLst/>
+          </a:prstGeom>
+          <a:noFill xmlns:a="http://schemas.openxmlformats.org/drawingml/2006/main"/>
+          <a:ln xmlns:a="http://schemas.openxmlformats.org/drawingml/2006/main" w="0">
+            <a:noFill/>
+            <a:prstDash val="solid"/>
+          </a:ln>
+        </p:spPr>
+        <p:txBody>
+          <a:bodyPr xmlns:a="http://schemas.openxmlformats.org/drawingml/2006/main"/>
+          <a:lstStyle xmlns:a="http://schemas.openxmlformats.org/drawingml/2006/main"/>
+          <a:p xmlns:a="http://schemas.openxmlformats.org/drawingml/2006/main">
+            <a:pPr>
+              <a:buNone/>
+              <a:defRPr sz="1350" b="1">
+                <a:solidFill>
+                  <a:srgbClr val="E45756"/>
+                </a:solidFill>
+              </a:defRPr>
+            </a:pPr>
+            <a:r>
+              <a:rPr sz="1350" b="1">
+                <a:solidFill>
+                  <a:srgbClr val="E45756"/>
+                </a:solidFill>
+              </a:rPr>
+              <a:t>STATE CONTRAST</a:t>
+            </a:r>
+          </a:p>
+        </p:txBody>
+      </p:sp>
+      <p:sp>
+        <p:nvSpPr>
+          <p:cNvPr id="2" name="">
+            <a:extLst xmlns:a="http://schemas.openxmlformats.org/drawingml/2006/main">
+              <a:ext uri="{FF2B5EF4-FFF2-40B4-BE49-F238E27FC236}">
+                <a16:creationId xmlns:a16="http://schemas.microsoft.com/office/drawing/2014/main" id="{0BB2094F-C042-49AB-BE8C-0ECFD22457DD}"/>
+              </a:ext>
+            </a:extLst>
+          </p:cNvPr>
+          <p:cNvSpPr>
+            <a:spLocks xmlns:a="http://schemas.openxmlformats.org/drawingml/2006/main" noGrp="1"/>
+          </p:cNvSpPr>
+          <p:nvPr/>
+        </p:nvSpPr>
+        <p:spPr>
+          <a:xfrm xmlns:a="http://schemas.openxmlformats.org/drawingml/2006/main">
+            <a:off x="457200" y="1562100"/>
+            <a:ext cx="10763250" cy="1809750"/>
+          </a:xfrm>
+          <a:prstGeom xmlns:a="http://schemas.openxmlformats.org/drawingml/2006/main" prst="rect">
+            <a:avLst/>
+          </a:prstGeom>
+          <a:noFill xmlns:a="http://schemas.openxmlformats.org/drawingml/2006/main"/>
+          <a:ln xmlns:a="http://schemas.openxmlformats.org/drawingml/2006/main" w="0">
+            <a:noFill/>
+            <a:prstDash val="solid"/>
+          </a:ln>
+        </p:spPr>
+        <p:txBody>
+          <a:bodyPr xmlns:a="http://schemas.openxmlformats.org/drawingml/2006/main"/>
+          <a:lstStyle xmlns:a="http://schemas.openxmlformats.org/drawingml/2006/main"/>
+          <a:p xmlns:a="http://schemas.openxmlformats.org/drawingml/2006/main">
+            <a:pPr>
+              <a:buNone/>
+              <a:defRPr sz="4350" b="1">
+                <a:solidFill>
+                  <a:srgbClr val="111827"/>
+                </a:solidFill>
+              </a:defRPr>
+            </a:pPr>
+            <a:r>
+              <a:rPr sz="4350" b="1">
+                <a:solidFill>
+                  <a:srgbClr val="111827"/>
+                </a:solidFill>
+              </a:rPr>
+              <a:t>Sideways versus trending: the approved comparison</a:t>
+            </a:r>
+          </a:p>
+        </p:txBody>
+      </p:sp>
+      <p:sp>
+        <p:nvSpPr>
+          <p:cNvPr id="3" name="">
+            <a:extLst xmlns:a="http://schemas.openxmlformats.org/drawingml/2006/main">
+              <a:ext uri="{FF2B5EF4-FFF2-40B4-BE49-F238E27FC236}">
+                <a16:creationId xmlns:a16="http://schemas.microsoft.com/office/drawing/2014/main" id="{D8394FB8-5765-4318-8A56-6DACECFE912E}"/>
+              </a:ext>
+            </a:extLst>
+          </p:cNvPr>
+          <p:cNvSpPr>
+            <a:spLocks xmlns:a="http://schemas.openxmlformats.org/drawingml/2006/main" noGrp="1"/>
+          </p:cNvSpPr>
+          <p:nvPr/>
+        </p:nvSpPr>
+        <p:spPr>
+          <a:xfrm xmlns:a="http://schemas.openxmlformats.org/drawingml/2006/main">
+            <a:off x="457200" y="3714750"/>
+            <a:ext cx="1257300" cy="76200"/>
+          </a:xfrm>
+          <a:prstGeom xmlns:a="http://schemas.openxmlformats.org/drawingml/2006/main" prst="rect">
+            <a:avLst/>
+          </a:prstGeom>
+          <a:solidFill xmlns:a="http://schemas.openxmlformats.org/drawingml/2006/main">
+            <a:srgbClr val="E45756"/>
+          </a:solidFill>
+          <a:ln xmlns:a="http://schemas.openxmlformats.org/drawingml/2006/main" w="9525">
+            <a:solidFill>
+              <a:srgbClr val="E45756"/>
+            </a:solidFill>
+            <a:prstDash val="solid"/>
+          </a:ln>
+        </p:spPr>
+      </p:sp>
+      <p:sp>
+        <p:nvSpPr>
+          <p:cNvPr id="4" name="">
+            <a:extLst xmlns:a="http://schemas.openxmlformats.org/drawingml/2006/main">
+              <a:ext uri="{FF2B5EF4-FFF2-40B4-BE49-F238E27FC236}">
+                <a16:creationId xmlns:a16="http://schemas.microsoft.com/office/drawing/2014/main" id="{67E3D676-3E4E-40CF-9FFA-FDD3E7F4C6B2}"/>
+              </a:ext>
+            </a:extLst>
+          </p:cNvPr>
+          <p:cNvSpPr>
+            <a:spLocks xmlns:a="http://schemas.openxmlformats.org/drawingml/2006/main" noGrp="1"/>
+          </p:cNvSpPr>
+          <p:nvPr/>
+        </p:nvSpPr>
+        <p:spPr>
+          <a:xfrm xmlns:a="http://schemas.openxmlformats.org/drawingml/2006/main">
+            <a:off x="457200" y="4171950"/>
+            <a:ext cx="9906000" cy="685800"/>
+          </a:xfrm>
+          <a:prstGeom xmlns:a="http://schemas.openxmlformats.org/drawingml/2006/main" prst="rect">
+            <a:avLst/>
+          </a:prstGeom>
+          <a:noFill xmlns:a="http://schemas.openxmlformats.org/drawingml/2006/main"/>
+          <a:ln xmlns:a="http://schemas.openxmlformats.org/drawingml/2006/main" w="0">
+            <a:noFill/>
+            <a:prstDash val="solid"/>
+          </a:ln>
+        </p:spPr>
+        <p:txBody>
+          <a:bodyPr xmlns:a="http://schemas.openxmlformats.org/drawingml/2006/main"/>
+          <a:lstStyle xmlns:a="http://schemas.openxmlformats.org/drawingml/2006/main"/>
+          <a:p xmlns:a="http://schemas.openxmlformats.org/drawingml/2006/main">
+            <a:pPr>
+              <a:buNone/>
+              <a:defRPr sz="2025" b="0">
+                <a:solidFill>
+                  <a:srgbClr val="667384"/>
+                </a:solidFill>
+              </a:defRPr>
+            </a:pPr>
+            <a:r>
+              <a:rPr sz="2025" b="0">
+                <a:solidFill>
+                  <a:srgbClr val="667384"/>
+                </a:solidFill>
+              </a:rPr>
+              <a:t>A paired descriptive contrast—not a strategy test</a:t>
+            </a:r>
+          </a:p>
+        </p:txBody>
+      </p:sp>
+      <p:sp>
+        <p:nvSpPr>
+          <p:cNvPr id="5" name="">
+            <a:extLst xmlns:a="http://schemas.openxmlformats.org/drawingml/2006/main">
+              <a:ext uri="{FF2B5EF4-FFF2-40B4-BE49-F238E27FC236}">
+                <a16:creationId xmlns:a16="http://schemas.microsoft.com/office/drawing/2014/main" id="{AF79BB13-9AEC-4C77-9A8C-3203F83002E1}"/>
+              </a:ext>
+            </a:extLst>
+          </p:cNvPr>
+          <p:cNvSpPr>
+            <a:spLocks xmlns:a="http://schemas.openxmlformats.org/drawingml/2006/main" noGrp="1"/>
+          </p:cNvSpPr>
+          <p:nvPr/>
+        </p:nvSpPr>
+        <p:spPr>
+          <a:xfrm xmlns:a="http://schemas.openxmlformats.org/drawingml/2006/main">
+            <a:off x="457200" y="5429250"/>
+            <a:ext cx="10477500" cy="609600"/>
+          </a:xfrm>
+          <a:prstGeom xmlns:a="http://schemas.openxmlformats.org/drawingml/2006/main" prst="rect">
+            <a:avLst/>
+          </a:prstGeom>
+          <a:noFill xmlns:a="http://schemas.openxmlformats.org/drawingml/2006/main"/>
+          <a:ln xmlns:a="http://schemas.openxmlformats.org/drawingml/2006/main" w="0">
+            <a:noFill/>
+            <a:prstDash val="solid"/>
+          </a:ln>
+        </p:spPr>
+        <p:txBody>
+          <a:bodyPr xmlns:a="http://schemas.openxmlformats.org/drawingml/2006/main"/>
+          <a:lstStyle xmlns:a="http://schemas.openxmlformats.org/drawingml/2006/main"/>
+          <a:p xmlns:a="http://schemas.openxmlformats.org/drawingml/2006/main">
+            <a:pPr>
+              <a:buNone/>
+              <a:defRPr sz="1575" b="0">
+                <a:solidFill>
+                  <a:srgbClr val="667384"/>
+                </a:solidFill>
+              </a:defRPr>
+            </a:pPr>
+            <a:r>
+              <a:rPr sz="1575" b="0">
+                <a:solidFill>
+                  <a:srgbClr val="667384"/>
+                </a:solidFill>
+              </a:rPr>
+              <a:t>Positive-prior branch • 15 × 15 horizons • 88-stock equal-sector core • post-2023 sealed</a:t>
+            </a:r>
+          </a:p>
+        </p:txBody>
+      </p:sp>
+      <p:sp>
+        <p:nvSpPr>
+          <p:cNvPr id="6" name="">
+            <a:extLst xmlns:a="http://schemas.openxmlformats.org/drawingml/2006/main">
+              <a:ext uri="{FF2B5EF4-FFF2-40B4-BE49-F238E27FC236}">
+                <a16:creationId xmlns:a16="http://schemas.microsoft.com/office/drawing/2014/main" id="{AD589277-BA8D-465E-8FE0-58FC0F7326BE}"/>
+              </a:ext>
+            </a:extLst>
+          </p:cNvPr>
+          <p:cNvSpPr>
+            <a:spLocks xmlns:a="http://schemas.openxmlformats.org/drawingml/2006/main" noGrp="1"/>
+          </p:cNvSpPr>
+          <p:nvPr/>
+        </p:nvSpPr>
+        <p:spPr>
+          <a:xfrm xmlns:a="http://schemas.openxmlformats.org/drawingml/2006/main">
+            <a:off x="11239500" y="6496050"/>
+            <a:ext cx="495300" cy="190500"/>
+          </a:xfrm>
+          <a:prstGeom xmlns:a="http://schemas.openxmlformats.org/drawingml/2006/main" prst="rect">
+            <a:avLst/>
+          </a:prstGeom>
+          <a:noFill xmlns:a="http://schemas.openxmlformats.org/drawingml/2006/main"/>
+          <a:ln xmlns:a="http://schemas.openxmlformats.org/drawingml/2006/main" w="0">
+            <a:noFill/>
+            <a:prstDash val="solid"/>
+          </a:ln>
+        </p:spPr>
+        <p:txBody>
+          <a:bodyPr xmlns:a="http://schemas.openxmlformats.org/drawingml/2006/main"/>
+          <a:lstStyle xmlns:a="http://schemas.openxmlformats.org/drawingml/2006/main"/>
+          <a:p xmlns:a="http://schemas.openxmlformats.org/drawingml/2006/main">
+            <a:pPr algn="r">
+              <a:buNone/>
+              <a:defRPr sz="900" b="0">
+                <a:solidFill>
+                  <a:srgbClr val="667384"/>
+                </a:solidFill>
+              </a:defRPr>
+            </a:pPr>
+            <a:r>
+              <a:rPr sz="900" b="0">
+                <a:solidFill>
+                  <a:srgbClr val="667384"/>
+                </a:solidFill>
+              </a:rPr>
+              <a:t>10</a:t>
+            </a:r>
+          </a:p>
+        </p:txBody>
+      </p:sp>
+    </p:spTree>
+    <p:extLst>
+      <p:ext uri="{BB962C8B-B14F-4D97-AF65-F5344CB8AC3E}">
+        <p14:creationId xmlns:p14="http://schemas.microsoft.com/office/powerpoint/2010/main" val="1697167073"/>
+      </p:ext>
+    </p:extLst>
+  </p:cSld>
+</p:sld>
+</file>
+
+<file path=ppt/slides/slide11.xml><?xml version="1.0" encoding="utf-8"?>
+<p:sld xmlns:p="http://schemas.openxmlformats.org/presentationml/2006/main">
+  <p:cSld>
+    <p:bg>
+      <p:bgPr>
+        <a:solidFill xmlns:a="http://schemas.openxmlformats.org/drawingml/2006/main">
+          <a:srgbClr val="FFFFFF"/>
+        </a:solidFill>
+      </p:bgPr>
+    </p:bg>
+    <p:spTree>
+      <p:nvGrpSpPr>
+        <p:cNvPr id="1" name=""/>
+        <p:cNvGrpSpPr/>
+        <p:nvPr/>
+      </p:nvGrpSpPr>
+      <p:grpSpPr>
+        <a:xfrm xmlns:a="http://schemas.openxmlformats.org/drawingml/2006/main"/>
+      </p:grpSpPr>
+      <p:sp>
+        <p:nvSpPr>
+          <p:cNvPr id="24" name="section-11">
+            <a:extLst xmlns:a="http://schemas.openxmlformats.org/drawingml/2006/main">
+              <a:ext uri="{FF2B5EF4-FFF2-40B4-BE49-F238E27FC236}">
+                <a16:creationId xmlns:a16="http://schemas.microsoft.com/office/drawing/2014/main" id="{272ED433-B59C-436C-9DFB-4D317B90A13F}"/>
+              </a:ext>
+            </a:extLst>
+          </p:cNvPr>
+          <p:cNvSpPr>
+            <a:spLocks xmlns:a="http://schemas.openxmlformats.org/drawingml/2006/main" noGrp="1"/>
+          </p:cNvSpPr>
+          <p:nvPr/>
+        </p:nvSpPr>
+        <p:spPr>
+          <a:xfrm xmlns:a="http://schemas.openxmlformats.org/drawingml/2006/main">
+            <a:off x="457200" y="228600"/>
+            <a:ext cx="4191000" cy="228600"/>
+          </a:xfrm>
+          <a:prstGeom xmlns:a="http://schemas.openxmlformats.org/drawingml/2006/main" prst="rect">
+            <a:avLst/>
+          </a:prstGeom>
+          <a:noFill xmlns:a="http://schemas.openxmlformats.org/drawingml/2006/main"/>
+          <a:ln xmlns:a="http://schemas.openxmlformats.org/drawingml/2006/main" w="0">
+            <a:noFill/>
+            <a:prstDash val="solid"/>
+          </a:ln>
+        </p:spPr>
+        <p:txBody>
+          <a:bodyPr xmlns:a="http://schemas.openxmlformats.org/drawingml/2006/main" wrap="square" lIns="0" tIns="0" rIns="0" bIns="0" anchor="t">
+            <a:normAutofit fontScale="100000"/>
+          </a:bodyPr>
+          <a:lstStyle xmlns:a="http://schemas.openxmlformats.org/drawingml/2006/main"/>
+          <a:p xmlns:a="http://schemas.openxmlformats.org/drawingml/2006/main">
+            <a:pPr algn="l">
+              <a:buNone/>
+              <a:defRPr sz="1200" b="1">
+                <a:solidFill>
+                  <a:srgbClr val="667384"/>
+                </a:solidFill>
+                <a:latin typeface="Arial"/>
+                <a:ea typeface="Arial"/>
+                <a:cs typeface="Arial"/>
+              </a:defRPr>
+            </a:pPr>
+            <a:r>
+              <a:rPr sz="1200" b="1">
+                <a:solidFill>
+                  <a:srgbClr val="667384"/>
+                </a:solidFill>
+                <a:latin typeface="Arial"/>
+                <a:ea typeface="Arial"/>
+                <a:cs typeface="Arial"/>
+              </a:rPr>
+              <a:t>STATE SURFACES</a:t>
+            </a:r>
+          </a:p>
+        </p:txBody>
+      </p:sp>
+      <p:sp>
+        <p:nvSpPr>
+          <p:cNvPr id="2" name="title-11">
+            <a:extLst xmlns:a="http://schemas.openxmlformats.org/drawingml/2006/main">
+              <a:ext uri="{FF2B5EF4-FFF2-40B4-BE49-F238E27FC236}">
+                <a16:creationId xmlns:a16="http://schemas.microsoft.com/office/drawing/2014/main" id="{3EC40708-7E00-432C-8ECE-907FA5705292}"/>
+              </a:ext>
+            </a:extLst>
+          </p:cNvPr>
+          <p:cNvSpPr>
+            <a:spLocks xmlns:a="http://schemas.openxmlformats.org/drawingml/2006/main" noGrp="1"/>
+          </p:cNvSpPr>
+          <p:nvPr/>
+        </p:nvSpPr>
+        <p:spPr>
+          <a:xfrm xmlns:a="http://schemas.openxmlformats.org/drawingml/2006/main">
+            <a:off x="457200" y="533400"/>
+            <a:ext cx="11277600" cy="628650"/>
+          </a:xfrm>
+          <a:prstGeom xmlns:a="http://schemas.openxmlformats.org/drawingml/2006/main" prst="rect">
+            <a:avLst/>
+          </a:prstGeom>
+          <a:noFill xmlns:a="http://schemas.openxmlformats.org/drawingml/2006/main"/>
+          <a:ln xmlns:a="http://schemas.openxmlformats.org/drawingml/2006/main" w="0">
+            <a:noFill/>
+            <a:prstDash val="solid"/>
+          </a:ln>
+        </p:spPr>
+        <p:txBody>
+          <a:bodyPr xmlns:a="http://schemas.openxmlformats.org/drawingml/2006/main" wrap="square" lIns="0" tIns="0" rIns="0" bIns="0" anchor="t">
+            <a:normAutofit fontScale="85754"/>
+          </a:bodyPr>
+          <a:lstStyle xmlns:a="http://schemas.openxmlformats.org/drawingml/2006/main"/>
+          <a:p xmlns:a="http://schemas.openxmlformats.org/drawingml/2006/main">
+            <a:pPr algn="l">
+              <a:buNone/>
+              <a:defRPr sz="3525" b="1">
+                <a:solidFill>
+                  <a:srgbClr val="000000"/>
+                </a:solidFill>
+                <a:latin typeface="Arial"/>
+                <a:ea typeface="Arial"/>
+                <a:cs typeface="Arial"/>
+              </a:defRPr>
+            </a:pPr>
+            <a:r>
+              <a:rPr sz="3525" b="1">
+                <a:solidFill>
+                  <a:srgbClr val="000000"/>
+                </a:solidFill>
+                <a:latin typeface="Arial"/>
+                <a:ea typeface="Arial"/>
+                <a:cs typeface="Arial"/>
+              </a:rPr>
+              <a:t>Sideways looks continuation-shaped; trending often does not</a:t>
+            </a:r>
+          </a:p>
+        </p:txBody>
+      </p:sp>
+      <p:sp>
+        <p:nvSpPr>
+          <p:cNvPr id="3" name="">
+            <a:extLst xmlns:a="http://schemas.openxmlformats.org/drawingml/2006/main">
+              <a:ext uri="{FF2B5EF4-FFF2-40B4-BE49-F238E27FC236}">
+                <a16:creationId xmlns:a16="http://schemas.microsoft.com/office/drawing/2014/main" id="{D5CA0FCE-75E8-41EF-A76A-23E9E2120C6A}"/>
+              </a:ext>
+            </a:extLst>
+          </p:cNvPr>
+          <p:cNvSpPr>
+            <a:spLocks xmlns:a="http://schemas.openxmlformats.org/drawingml/2006/main" noGrp="1"/>
+          </p:cNvSpPr>
+          <p:nvPr/>
+        </p:nvSpPr>
+        <p:spPr>
+          <a:xfrm xmlns:a="http://schemas.openxmlformats.org/drawingml/2006/main">
+            <a:off x="457200" y="1200150"/>
+            <a:ext cx="11277600" cy="19050"/>
+          </a:xfrm>
+          <a:prstGeom xmlns:a="http://schemas.openxmlformats.org/drawingml/2006/main" prst="rect">
+            <a:avLst/>
+          </a:prstGeom>
+          <a:solidFill xmlns:a="http://schemas.openxmlformats.org/drawingml/2006/main">
+            <a:srgbClr val="B8BCC4"/>
+          </a:solidFill>
+          <a:ln xmlns:a="http://schemas.openxmlformats.org/drawingml/2006/main" w="0">
+            <a:solidFill>
+              <a:srgbClr val="B8BCC4"/>
+            </a:solidFill>
+            <a:prstDash val="solid"/>
+          </a:ln>
+        </p:spPr>
+      </p:sp>
+      <p:sp>
+        <p:nvSpPr>
+          <p:cNvPr id="4" name="footer-left-11">
+            <a:extLst xmlns:a="http://schemas.openxmlformats.org/drawingml/2006/main">
+              <a:ext uri="{FF2B5EF4-FFF2-40B4-BE49-F238E27FC236}">
+                <a16:creationId xmlns:a16="http://schemas.microsoft.com/office/drawing/2014/main" id="{700DA765-80E0-4197-8700-00D867B86FA2}"/>
+              </a:ext>
+            </a:extLst>
+          </p:cNvPr>
+          <p:cNvSpPr>
+            <a:spLocks xmlns:a="http://schemas.openxmlformats.org/drawingml/2006/main" noGrp="1"/>
+          </p:cNvSpPr>
+          <p:nvPr/>
+        </p:nvSpPr>
+        <p:spPr>
+          <a:xfrm xmlns:a="http://schemas.openxmlformats.org/drawingml/2006/main">
+            <a:off x="457200" y="6515100"/>
+            <a:ext cx="3429000" cy="171450"/>
+          </a:xfrm>
+          <a:prstGeom xmlns:a="http://schemas.openxmlformats.org/drawingml/2006/main" prst="rect">
+            <a:avLst/>
+          </a:prstGeom>
+          <a:noFill xmlns:a="http://schemas.openxmlformats.org/drawingml/2006/main"/>
+          <a:ln xmlns:a="http://schemas.openxmlformats.org/drawingml/2006/main" w="0">
+            <a:noFill/>
+            <a:prstDash val="solid"/>
+          </a:ln>
+        </p:spPr>
+        <p:txBody>
+          <a:bodyPr xmlns:a="http://schemas.openxmlformats.org/drawingml/2006/main" wrap="square" lIns="0" tIns="0" rIns="0" bIns="0" anchor="t">
+            <a:normAutofit fontScale="100000"/>
+          </a:bodyPr>
+          <a:lstStyle xmlns:a="http://schemas.openxmlformats.org/drawingml/2006/main"/>
+          <a:p xmlns:a="http://schemas.openxmlformats.org/drawingml/2006/main">
+            <a:pPr algn="l">
+              <a:buNone/>
+              <a:defRPr sz="825" b="0">
+                <a:solidFill>
+                  <a:srgbClr val="64748B"/>
+                </a:solidFill>
+                <a:latin typeface="Arial"/>
+                <a:ea typeface="Arial"/>
+                <a:cs typeface="Arial"/>
+              </a:defRPr>
+            </a:pPr>
+            <a:r>
+              <a:rPr sz="825" b="0">
+                <a:solidFill>
+                  <a:srgbClr val="64748B"/>
+                </a:solidFill>
+                <a:latin typeface="Arial"/>
+                <a:ea typeface="Arial"/>
+                <a:cs typeface="Arial"/>
+              </a:rPr>
+              <a:t>88-stock core | paired positive-prior branch | equal-sector medians</a:t>
+            </a:r>
+          </a:p>
+        </p:txBody>
+      </p:sp>
+      <p:sp>
+        <p:nvSpPr>
+          <p:cNvPr id="5" name="footer-number-11">
+            <a:extLst xmlns:a="http://schemas.openxmlformats.org/drawingml/2006/main">
+              <a:ext uri="{FF2B5EF4-FFF2-40B4-BE49-F238E27FC236}">
+                <a16:creationId xmlns:a16="http://schemas.microsoft.com/office/drawing/2014/main" id="{83896276-4112-4532-AF7C-776C67C58B77}"/>
+              </a:ext>
+            </a:extLst>
+          </p:cNvPr>
+          <p:cNvSpPr>
+            <a:spLocks xmlns:a="http://schemas.openxmlformats.org/drawingml/2006/main" noGrp="1"/>
+          </p:cNvSpPr>
+          <p:nvPr/>
+        </p:nvSpPr>
+        <p:spPr>
+          <a:xfrm xmlns:a="http://schemas.openxmlformats.org/drawingml/2006/main">
+            <a:off x="10477500" y="6496050"/>
+            <a:ext cx="1257300" cy="190500"/>
+          </a:xfrm>
+          <a:prstGeom xmlns:a="http://schemas.openxmlformats.org/drawingml/2006/main" prst="rect">
+            <a:avLst/>
+          </a:prstGeom>
+          <a:noFill xmlns:a="http://schemas.openxmlformats.org/drawingml/2006/main"/>
+          <a:ln xmlns:a="http://schemas.openxmlformats.org/drawingml/2006/main" w="0">
+            <a:noFill/>
+            <a:prstDash val="solid"/>
+          </a:ln>
+        </p:spPr>
+        <p:txBody>
+          <a:bodyPr xmlns:a="http://schemas.openxmlformats.org/drawingml/2006/main" wrap="square" lIns="0" tIns="0" rIns="0" bIns="0" anchor="t">
+            <a:normAutofit fontScale="100000"/>
+          </a:bodyPr>
+          <a:lstStyle xmlns:a="http://schemas.openxmlformats.org/drawingml/2006/main"/>
+          <a:p xmlns:a="http://schemas.openxmlformats.org/drawingml/2006/main">
+            <a:pPr algn="r">
+              <a:buNone/>
+              <a:defRPr sz="1050" b="0">
+                <a:solidFill>
+                  <a:srgbClr val="667384"/>
+                </a:solidFill>
+                <a:latin typeface="Arial"/>
+                <a:ea typeface="Arial"/>
+                <a:cs typeface="Arial"/>
+              </a:defRPr>
+            </a:pPr>
+            <a:r>
+              <a:rPr sz="1050" b="0">
+                <a:solidFill>
+                  <a:srgbClr val="667384"/>
+                </a:solidFill>
+                <a:latin typeface="Arial"/>
+                <a:ea typeface="Arial"/>
+                <a:cs typeface="Arial"/>
+              </a:rPr>
+              <a:t>11</a:t>
+            </a:r>
+          </a:p>
+        </p:txBody>
+      </p:sp>
+      <p:pic>
+        <p:nvPicPr>
+          <p:cNvPr id="31" name=""/>
+          <p:cNvPicPr>
+            <a:picLocks xmlns:a="http://schemas.openxmlformats.org/drawingml/2006/main" noChangeAspect="1"/>
+          </p:cNvPicPr>
+          <p:nvPr/>
+        </p:nvPicPr>
+        <p:blipFill>
+          <a:blip xmlns:r="http://schemas.openxmlformats.org/officeDocument/2006/relationships" xmlns:a="http://schemas.openxmlformats.org/drawingml/2006/main" r:embed="R00d18af808c14119"/>
+          <a:stretch xmlns:a="http://schemas.openxmlformats.org/drawingml/2006/main"/>
+        </p:blipFill>
+        <p:spPr>
+          <a:xfrm xmlns:a="http://schemas.openxmlformats.org/drawingml/2006/main">
+            <a:off x="2885498" y="2240483"/>
+            <a:ext cx="6421005" cy="3234284"/>
+          </a:xfrm>
+          <a:prstGeom xmlns:a="http://schemas.openxmlformats.org/drawingml/2006/main" prst="rect">
+            <a:avLst/>
+          </a:prstGeom>
+        </p:spPr>
+      </p:pic>
+    </p:spTree>
+    <p:extLst>
+      <p:ext uri="{BB962C8B-B14F-4D97-AF65-F5344CB8AC3E}">
+        <p14:creationId xmlns:p14="http://schemas.microsoft.com/office/powerpoint/2010/main" val="666536286"/>
+      </p:ext>
+    </p:extLst>
+  </p:cSld>
+</p:sld>
+</file>
+
+<file path=ppt/slides/slide12.xml><?xml version="1.0" encoding="utf-8"?>
+<p:sld xmlns:p="http://schemas.openxmlformats.org/presentationml/2006/main">
+  <p:cSld>
+    <p:bg>
+      <p:bgPr>
+        <a:solidFill xmlns:a="http://schemas.openxmlformats.org/drawingml/2006/main">
+          <a:srgbClr val="FFFFFF"/>
+        </a:solidFill>
+      </p:bgPr>
+    </p:bg>
+    <p:spTree>
+      <p:nvGrpSpPr>
+        <p:cNvPr id="1" name=""/>
+        <p:cNvGrpSpPr/>
+        <p:nvPr/>
+      </p:nvGrpSpPr>
+      <p:grpSpPr>
+        <a:xfrm xmlns:a="http://schemas.openxmlformats.org/drawingml/2006/main"/>
+      </p:grpSpPr>
+      <p:sp>
+        <p:nvSpPr>
+          <p:cNvPr id="24" name="section-11">
+            <a:extLst xmlns:a="http://schemas.openxmlformats.org/drawingml/2006/main">
+              <a:ext uri="{FF2B5EF4-FFF2-40B4-BE49-F238E27FC236}">
+                <a16:creationId xmlns:a16="http://schemas.microsoft.com/office/drawing/2014/main" id="{272ED433-B59C-436C-9DFB-4D317B90A13F}"/>
+              </a:ext>
+            </a:extLst>
+          </p:cNvPr>
+          <p:cNvSpPr>
+            <a:spLocks xmlns:a="http://schemas.openxmlformats.org/drawingml/2006/main" noGrp="1"/>
+          </p:cNvSpPr>
+          <p:nvPr/>
+        </p:nvSpPr>
+        <p:spPr>
+          <a:xfrm xmlns:a="http://schemas.openxmlformats.org/drawingml/2006/main">
+            <a:off x="457200" y="228600"/>
+            <a:ext cx="4191000" cy="228600"/>
+          </a:xfrm>
+          <a:prstGeom xmlns:a="http://schemas.openxmlformats.org/drawingml/2006/main" prst="rect">
+            <a:avLst/>
+          </a:prstGeom>
+          <a:noFill xmlns:a="http://schemas.openxmlformats.org/drawingml/2006/main"/>
+          <a:ln xmlns:a="http://schemas.openxmlformats.org/drawingml/2006/main" w="0">
+            <a:noFill/>
+            <a:prstDash val="solid"/>
+          </a:ln>
+        </p:spPr>
+        <p:txBody>
+          <a:bodyPr xmlns:a="http://schemas.openxmlformats.org/drawingml/2006/main" wrap="square" lIns="0" tIns="0" rIns="0" bIns="0" anchor="t">
+            <a:normAutofit fontScale="100000"/>
+          </a:bodyPr>
+          <a:lstStyle xmlns:a="http://schemas.openxmlformats.org/drawingml/2006/main"/>
+          <a:p xmlns:a="http://schemas.openxmlformats.org/drawingml/2006/main">
+            <a:pPr algn="l">
+              <a:buNone/>
+              <a:defRPr sz="1200" b="1">
+                <a:solidFill>
+                  <a:srgbClr val="667384"/>
+                </a:solidFill>
+                <a:latin typeface="Arial"/>
+                <a:ea typeface="Arial"/>
+                <a:cs typeface="Arial"/>
+              </a:defRPr>
+            </a:pPr>
+            <a:r>
+              <a:rPr sz="1200" b="1">
+                <a:solidFill>
+                  <a:srgbClr val="667384"/>
+                </a:solidFill>
+                <a:latin typeface="Arial"/>
+                <a:ea typeface="Arial"/>
+                <a:cs typeface="Arial"/>
+              </a:rPr>
+              <a:t>PAIRED CONTRAST</a:t>
+            </a:r>
+          </a:p>
+        </p:txBody>
+      </p:sp>
+      <p:sp>
+        <p:nvSpPr>
+          <p:cNvPr id="2" name="title-11">
+            <a:extLst xmlns:a="http://schemas.openxmlformats.org/drawingml/2006/main">
+              <a:ext uri="{FF2B5EF4-FFF2-40B4-BE49-F238E27FC236}">
+                <a16:creationId xmlns:a16="http://schemas.microsoft.com/office/drawing/2014/main" id="{3EC40708-7E00-432C-8ECE-907FA5705292}"/>
+              </a:ext>
+            </a:extLst>
+          </p:cNvPr>
+          <p:cNvSpPr>
+            <a:spLocks xmlns:a="http://schemas.openxmlformats.org/drawingml/2006/main" noGrp="1"/>
+          </p:cNvSpPr>
+          <p:nvPr/>
+        </p:nvSpPr>
+        <p:spPr>
+          <a:xfrm xmlns:a="http://schemas.openxmlformats.org/drawingml/2006/main">
+            <a:off x="457200" y="533400"/>
+            <a:ext cx="11277600" cy="628650"/>
+          </a:xfrm>
+          <a:prstGeom xmlns:a="http://schemas.openxmlformats.org/drawingml/2006/main" prst="rect">
+            <a:avLst/>
+          </a:prstGeom>
+          <a:noFill xmlns:a="http://schemas.openxmlformats.org/drawingml/2006/main"/>
+          <a:ln xmlns:a="http://schemas.openxmlformats.org/drawingml/2006/main" w="0">
+            <a:noFill/>
+            <a:prstDash val="solid"/>
+          </a:ln>
+        </p:spPr>
+        <p:txBody>
+          <a:bodyPr xmlns:a="http://schemas.openxmlformats.org/drawingml/2006/main" wrap="square" lIns="0" tIns="0" rIns="0" bIns="0" anchor="t">
+            <a:normAutofit fontScale="100000"/>
+          </a:bodyPr>
+          <a:lstStyle xmlns:a="http://schemas.openxmlformats.org/drawingml/2006/main"/>
+          <a:p xmlns:a="http://schemas.openxmlformats.org/drawingml/2006/main">
+            <a:pPr algn="l">
+              <a:buNone/>
+              <a:defRPr sz="3525" b="1">
+                <a:solidFill>
+                  <a:srgbClr val="000000"/>
+                </a:solidFill>
+                <a:latin typeface="Arial"/>
+                <a:ea typeface="Arial"/>
+                <a:cs typeface="Arial"/>
+              </a:defRPr>
+            </a:pPr>
+            <a:r>
+              <a:rPr sz="3525" b="1">
+                <a:solidFill>
+                  <a:srgbClr val="000000"/>
+                </a:solidFill>
+                <a:latin typeface="Arial"/>
+                <a:ea typeface="Arial"/>
+                <a:cs typeface="Arial"/>
+              </a:rPr>
+              <a:t>Sideways wins 92.9% of paired horizon cells</a:t>
+            </a:r>
+          </a:p>
+        </p:txBody>
+      </p:sp>
+      <p:sp>
+        <p:nvSpPr>
+          <p:cNvPr id="3" name="">
+            <a:extLst xmlns:a="http://schemas.openxmlformats.org/drawingml/2006/main">
+              <a:ext uri="{FF2B5EF4-FFF2-40B4-BE49-F238E27FC236}">
+                <a16:creationId xmlns:a16="http://schemas.microsoft.com/office/drawing/2014/main" id="{D5CA0FCE-75E8-41EF-A76A-23E9E2120C6A}"/>
+              </a:ext>
+            </a:extLst>
+          </p:cNvPr>
+          <p:cNvSpPr>
+            <a:spLocks xmlns:a="http://schemas.openxmlformats.org/drawingml/2006/main" noGrp="1"/>
+          </p:cNvSpPr>
+          <p:nvPr/>
+        </p:nvSpPr>
+        <p:spPr>
+          <a:xfrm xmlns:a="http://schemas.openxmlformats.org/drawingml/2006/main">
+            <a:off x="457200" y="1200150"/>
+            <a:ext cx="11277600" cy="19050"/>
+          </a:xfrm>
+          <a:prstGeom xmlns:a="http://schemas.openxmlformats.org/drawingml/2006/main" prst="rect">
+            <a:avLst/>
+          </a:prstGeom>
+          <a:solidFill xmlns:a="http://schemas.openxmlformats.org/drawingml/2006/main">
+            <a:srgbClr val="B8BCC4"/>
+          </a:solidFill>
+          <a:ln xmlns:a="http://schemas.openxmlformats.org/drawingml/2006/main" w="0">
+            <a:solidFill>
+              <a:srgbClr val="B8BCC4"/>
+            </a:solidFill>
+            <a:prstDash val="solid"/>
+          </a:ln>
+        </p:spPr>
+      </p:sp>
+      <p:sp>
+        <p:nvSpPr>
+          <p:cNvPr id="4" name="footer-left-11">
+            <a:extLst xmlns:a="http://schemas.openxmlformats.org/drawingml/2006/main">
+              <a:ext uri="{FF2B5EF4-FFF2-40B4-BE49-F238E27FC236}">
+                <a16:creationId xmlns:a16="http://schemas.microsoft.com/office/drawing/2014/main" id="{700DA765-80E0-4197-8700-00D867B86FA2}"/>
+              </a:ext>
+            </a:extLst>
+          </p:cNvPr>
+          <p:cNvSpPr>
+            <a:spLocks xmlns:a="http://schemas.openxmlformats.org/drawingml/2006/main" noGrp="1"/>
+          </p:cNvSpPr>
+          <p:nvPr/>
+        </p:nvSpPr>
+        <p:spPr>
+          <a:xfrm xmlns:a="http://schemas.openxmlformats.org/drawingml/2006/main">
+            <a:off x="457200" y="6515100"/>
+            <a:ext cx="3429000" cy="171450"/>
+          </a:xfrm>
+          <a:prstGeom xmlns:a="http://schemas.openxmlformats.org/drawingml/2006/main" prst="rect">
+            <a:avLst/>
+          </a:prstGeom>
+          <a:noFill xmlns:a="http://schemas.openxmlformats.org/drawingml/2006/main"/>
+          <a:ln xmlns:a="http://schemas.openxmlformats.org/drawingml/2006/main" w="0">
+            <a:noFill/>
+            <a:prstDash val="solid"/>
+          </a:ln>
+        </p:spPr>
+        <p:txBody>
+          <a:bodyPr xmlns:a="http://schemas.openxmlformats.org/drawingml/2006/main" wrap="square" lIns="0" tIns="0" rIns="0" bIns="0" anchor="t">
+            <a:normAutofit fontScale="100000"/>
+          </a:bodyPr>
+          <a:lstStyle xmlns:a="http://schemas.openxmlformats.org/drawingml/2006/main"/>
+          <a:p xmlns:a="http://schemas.openxmlformats.org/drawingml/2006/main">
+            <a:pPr algn="l">
+              <a:buNone/>
+              <a:defRPr sz="825" b="0">
+                <a:solidFill>
+                  <a:srgbClr val="64748B"/>
+                </a:solidFill>
+                <a:latin typeface="Arial"/>
+                <a:ea typeface="Arial"/>
+                <a:cs typeface="Arial"/>
+              </a:defRPr>
+            </a:pPr>
+            <a:r>
+              <a:rPr sz="825" b="0">
+                <a:solidFill>
+                  <a:srgbClr val="64748B"/>
+                </a:solidFill>
+                <a:latin typeface="Arial"/>
+                <a:ea typeface="Arial"/>
+                <a:cs typeface="Arial"/>
+              </a:rPr>
+              <a:t>Sideways r minus trending r | paired within asset and horizon cell</a:t>
+            </a:r>
+          </a:p>
+        </p:txBody>
+      </p:sp>
+      <p:sp>
+        <p:nvSpPr>
+          <p:cNvPr id="5" name="footer-number-11">
+            <a:extLst xmlns:a="http://schemas.openxmlformats.org/drawingml/2006/main">
+              <a:ext uri="{FF2B5EF4-FFF2-40B4-BE49-F238E27FC236}">
+                <a16:creationId xmlns:a16="http://schemas.microsoft.com/office/drawing/2014/main" id="{83896276-4112-4532-AF7C-776C67C58B77}"/>
+              </a:ext>
+            </a:extLst>
+          </p:cNvPr>
+          <p:cNvSpPr>
+            <a:spLocks xmlns:a="http://schemas.openxmlformats.org/drawingml/2006/main" noGrp="1"/>
+          </p:cNvSpPr>
+          <p:nvPr/>
+        </p:nvSpPr>
+        <p:spPr>
+          <a:xfrm xmlns:a="http://schemas.openxmlformats.org/drawingml/2006/main">
+            <a:off x="10477500" y="6496050"/>
+            <a:ext cx="1257300" cy="190500"/>
+          </a:xfrm>
+          <a:prstGeom xmlns:a="http://schemas.openxmlformats.org/drawingml/2006/main" prst="rect">
+            <a:avLst/>
+          </a:prstGeom>
+          <a:noFill xmlns:a="http://schemas.openxmlformats.org/drawingml/2006/main"/>
+          <a:ln xmlns:a="http://schemas.openxmlformats.org/drawingml/2006/main" w="0">
+            <a:noFill/>
+            <a:prstDash val="solid"/>
+          </a:ln>
+        </p:spPr>
+        <p:txBody>
+          <a:bodyPr xmlns:a="http://schemas.openxmlformats.org/drawingml/2006/main" wrap="square" lIns="0" tIns="0" rIns="0" bIns="0" anchor="t">
+            <a:normAutofit fontScale="100000"/>
+          </a:bodyPr>
+          <a:lstStyle xmlns:a="http://schemas.openxmlformats.org/drawingml/2006/main"/>
+          <a:p xmlns:a="http://schemas.openxmlformats.org/drawingml/2006/main">
+            <a:pPr algn="r">
+              <a:buNone/>
+              <a:defRPr sz="1050" b="0">
+                <a:solidFill>
+                  <a:srgbClr val="667384"/>
+                </a:solidFill>
+                <a:latin typeface="Arial"/>
+                <a:ea typeface="Arial"/>
+                <a:cs typeface="Arial"/>
+              </a:defRPr>
+            </a:pPr>
+            <a:r>
+              <a:rPr sz="1050" b="0">
+                <a:solidFill>
+                  <a:srgbClr val="667384"/>
+                </a:solidFill>
+                <a:latin typeface="Arial"/>
+                <a:ea typeface="Arial"/>
+                <a:cs typeface="Arial"/>
+              </a:rPr>
+              <a:t>12</a:t>
+            </a:r>
+          </a:p>
+        </p:txBody>
+      </p:sp>
+      <p:pic>
+        <p:nvPicPr>
+          <p:cNvPr id="31" name=""/>
+          <p:cNvPicPr>
+            <a:picLocks xmlns:a="http://schemas.openxmlformats.org/drawingml/2006/main" noChangeAspect="1"/>
+          </p:cNvPicPr>
+          <p:nvPr/>
+        </p:nvPicPr>
+        <p:blipFill>
+          <a:blip xmlns:r="http://schemas.openxmlformats.org/officeDocument/2006/relationships" xmlns:a="http://schemas.openxmlformats.org/drawingml/2006/main" r:embed="R5b993ed231214726"/>
+          <a:stretch xmlns:a="http://schemas.openxmlformats.org/drawingml/2006/main"/>
+        </p:blipFill>
+        <p:spPr>
+          <a:xfrm xmlns:a="http://schemas.openxmlformats.org/drawingml/2006/main">
+            <a:off x="2885498" y="1421672"/>
+            <a:ext cx="6421005" cy="4871905"/>
+          </a:xfrm>
+          <a:prstGeom xmlns:a="http://schemas.openxmlformats.org/drawingml/2006/main" prst="rect">
+            <a:avLst/>
+          </a:prstGeom>
+        </p:spPr>
+      </p:pic>
+    </p:spTree>
+    <p:extLst>
+      <p:ext uri="{BB962C8B-B14F-4D97-AF65-F5344CB8AC3E}">
+        <p14:creationId xmlns:p14="http://schemas.microsoft.com/office/powerpoint/2010/main" val="666536286"/>
+      </p:ext>
+    </p:extLst>
+  </p:cSld>
+</p:sld>
+</file>
+
+<file path=ppt/slides/slide13.xml><?xml version="1.0" encoding="utf-8"?>
+<p:sld xmlns:p="http://schemas.openxmlformats.org/presentationml/2006/main">
+  <p:cSld>
+    <p:bg>
+      <p:bgPr>
+        <a:solidFill xmlns:a="http://schemas.openxmlformats.org/drawingml/2006/main">
+          <a:srgbClr val="FFFFFF"/>
+        </a:solidFill>
+      </p:bgPr>
+    </p:bg>
+    <p:spTree>
+      <p:nvGrpSpPr>
+        <p:cNvPr id="1" name=""/>
+        <p:cNvGrpSpPr/>
+        <p:nvPr/>
+      </p:nvGrpSpPr>
+      <p:grpSpPr>
+        <a:xfrm xmlns:a="http://schemas.openxmlformats.org/drawingml/2006/main"/>
+      </p:grpSpPr>
+      <p:sp>
+        <p:nvSpPr>
+          <p:cNvPr id="24" name="section-11">
+            <a:extLst xmlns:a="http://schemas.openxmlformats.org/drawingml/2006/main">
+              <a:ext uri="{FF2B5EF4-FFF2-40B4-BE49-F238E27FC236}">
+                <a16:creationId xmlns:a16="http://schemas.microsoft.com/office/drawing/2014/main" id="{272ED433-B59C-436C-9DFB-4D317B90A13F}"/>
+              </a:ext>
+            </a:extLst>
+          </p:cNvPr>
+          <p:cNvSpPr>
+            <a:spLocks xmlns:a="http://schemas.openxmlformats.org/drawingml/2006/main" noGrp="1"/>
+          </p:cNvSpPr>
+          <p:nvPr/>
+        </p:nvSpPr>
+        <p:spPr>
+          <a:xfrm xmlns:a="http://schemas.openxmlformats.org/drawingml/2006/main">
+            <a:off x="457200" y="228600"/>
+            <a:ext cx="4191000" cy="228600"/>
+          </a:xfrm>
+          <a:prstGeom xmlns:a="http://schemas.openxmlformats.org/drawingml/2006/main" prst="rect">
+            <a:avLst/>
+          </a:prstGeom>
+          <a:noFill xmlns:a="http://schemas.openxmlformats.org/drawingml/2006/main"/>
+          <a:ln xmlns:a="http://schemas.openxmlformats.org/drawingml/2006/main" w="0">
+            <a:noFill/>
+            <a:prstDash val="solid"/>
+          </a:ln>
+        </p:spPr>
+        <p:txBody>
+          <a:bodyPr xmlns:a="http://schemas.openxmlformats.org/drawingml/2006/main" wrap="square" lIns="0" tIns="0" rIns="0" bIns="0" anchor="t">
+            <a:normAutofit fontScale="100000"/>
+          </a:bodyPr>
+          <a:lstStyle xmlns:a="http://schemas.openxmlformats.org/drawingml/2006/main"/>
+          <a:p xmlns:a="http://schemas.openxmlformats.org/drawingml/2006/main">
+            <a:pPr algn="l">
+              <a:buNone/>
+              <a:defRPr sz="1200" b="1">
+                <a:solidFill>
+                  <a:srgbClr val="667384"/>
+                </a:solidFill>
+                <a:latin typeface="Arial"/>
+                <a:ea typeface="Arial"/>
+                <a:cs typeface="Arial"/>
+              </a:defRPr>
+            </a:pPr>
+            <a:r>
+              <a:rPr sz="1200" b="1">
+                <a:solidFill>
+                  <a:srgbClr val="667384"/>
+                </a:solidFill>
+                <a:latin typeface="Arial"/>
+                <a:ea typeface="Arial"/>
+                <a:cs typeface="Arial"/>
+              </a:rPr>
+              <a:t>SECTOR CONTEXT</a:t>
+            </a:r>
+          </a:p>
+        </p:txBody>
+      </p:sp>
+      <p:sp>
+        <p:nvSpPr>
+          <p:cNvPr id="2" name="title-11">
+            <a:extLst xmlns:a="http://schemas.openxmlformats.org/drawingml/2006/main">
+              <a:ext uri="{FF2B5EF4-FFF2-40B4-BE49-F238E27FC236}">
+                <a16:creationId xmlns:a16="http://schemas.microsoft.com/office/drawing/2014/main" id="{3EC40708-7E00-432C-8ECE-907FA5705292}"/>
+              </a:ext>
+            </a:extLst>
+          </p:cNvPr>
+          <p:cNvSpPr>
+            <a:spLocks xmlns:a="http://schemas.openxmlformats.org/drawingml/2006/main" noGrp="1"/>
+          </p:cNvSpPr>
+          <p:nvPr/>
+        </p:nvSpPr>
+        <p:spPr>
+          <a:xfrm xmlns:a="http://schemas.openxmlformats.org/drawingml/2006/main">
+            <a:off x="457200" y="533400"/>
+            <a:ext cx="11277600" cy="628650"/>
+          </a:xfrm>
+          <a:prstGeom xmlns:a="http://schemas.openxmlformats.org/drawingml/2006/main" prst="rect">
+            <a:avLst/>
+          </a:prstGeom>
+          <a:noFill xmlns:a="http://schemas.openxmlformats.org/drawingml/2006/main"/>
+          <a:ln xmlns:a="http://schemas.openxmlformats.org/drawingml/2006/main" w="0">
+            <a:noFill/>
+            <a:prstDash val="solid"/>
+          </a:ln>
+        </p:spPr>
+        <p:txBody>
+          <a:bodyPr xmlns:a="http://schemas.openxmlformats.org/drawingml/2006/main" wrap="square" lIns="0" tIns="0" rIns="0" bIns="0" anchor="t">
+            <a:normAutofit fontScale="100000"/>
+          </a:bodyPr>
+          <a:lstStyle xmlns:a="http://schemas.openxmlformats.org/drawingml/2006/main"/>
+          <a:p xmlns:a="http://schemas.openxmlformats.org/drawingml/2006/main">
+            <a:pPr algn="l">
+              <a:buNone/>
+              <a:defRPr sz="3525" b="1">
+                <a:solidFill>
+                  <a:srgbClr val="000000"/>
+                </a:solidFill>
+                <a:latin typeface="Arial"/>
+                <a:ea typeface="Arial"/>
+                <a:cs typeface="Arial"/>
+              </a:defRPr>
+            </a:pPr>
+            <a:r>
+              <a:rPr sz="3525" b="1">
+                <a:solidFill>
+                  <a:srgbClr val="000000"/>
+                </a:solidFill>
+                <a:latin typeface="Arial"/>
+                <a:ea typeface="Arial"/>
+                <a:cs typeface="Arial"/>
+              </a:rPr>
+              <a:t>All 11 sectors favor sideways on their median cell</a:t>
+            </a:r>
+          </a:p>
+        </p:txBody>
+      </p:sp>
+      <p:sp>
+        <p:nvSpPr>
+          <p:cNvPr id="3" name="">
+            <a:extLst xmlns:a="http://schemas.openxmlformats.org/drawingml/2006/main">
+              <a:ext uri="{FF2B5EF4-FFF2-40B4-BE49-F238E27FC236}">
+                <a16:creationId xmlns:a16="http://schemas.microsoft.com/office/drawing/2014/main" id="{D5CA0FCE-75E8-41EF-A76A-23E9E2120C6A}"/>
+              </a:ext>
+            </a:extLst>
+          </p:cNvPr>
+          <p:cNvSpPr>
+            <a:spLocks xmlns:a="http://schemas.openxmlformats.org/drawingml/2006/main" noGrp="1"/>
+          </p:cNvSpPr>
+          <p:nvPr/>
+        </p:nvSpPr>
+        <p:spPr>
+          <a:xfrm xmlns:a="http://schemas.openxmlformats.org/drawingml/2006/main">
+            <a:off x="457200" y="1200150"/>
+            <a:ext cx="11277600" cy="19050"/>
+          </a:xfrm>
+          <a:prstGeom xmlns:a="http://schemas.openxmlformats.org/drawingml/2006/main" prst="rect">
+            <a:avLst/>
+          </a:prstGeom>
+          <a:solidFill xmlns:a="http://schemas.openxmlformats.org/drawingml/2006/main">
+            <a:srgbClr val="B8BCC4"/>
+          </a:solidFill>
+          <a:ln xmlns:a="http://schemas.openxmlformats.org/drawingml/2006/main" w="0">
+            <a:solidFill>
+              <a:srgbClr val="B8BCC4"/>
+            </a:solidFill>
+            <a:prstDash val="solid"/>
+          </a:ln>
+        </p:spPr>
+      </p:sp>
+      <p:sp>
+        <p:nvSpPr>
+          <p:cNvPr id="4" name="footer-left-11">
+            <a:extLst xmlns:a="http://schemas.openxmlformats.org/drawingml/2006/main">
+              <a:ext uri="{FF2B5EF4-FFF2-40B4-BE49-F238E27FC236}">
+                <a16:creationId xmlns:a16="http://schemas.microsoft.com/office/drawing/2014/main" id="{700DA765-80E0-4197-8700-00D867B86FA2}"/>
+              </a:ext>
+            </a:extLst>
+          </p:cNvPr>
+          <p:cNvSpPr>
+            <a:spLocks xmlns:a="http://schemas.openxmlformats.org/drawingml/2006/main" noGrp="1"/>
+          </p:cNvSpPr>
+          <p:nvPr/>
+        </p:nvSpPr>
+        <p:spPr>
+          <a:xfrm xmlns:a="http://schemas.openxmlformats.org/drawingml/2006/main">
+            <a:off x="457200" y="6515100"/>
+            <a:ext cx="3429000" cy="171450"/>
+          </a:xfrm>
+          <a:prstGeom xmlns:a="http://schemas.openxmlformats.org/drawingml/2006/main" prst="rect">
+            <a:avLst/>
+          </a:prstGeom>
+          <a:noFill xmlns:a="http://schemas.openxmlformats.org/drawingml/2006/main"/>
+          <a:ln xmlns:a="http://schemas.openxmlformats.org/drawingml/2006/main" w="0">
+            <a:noFill/>
+            <a:prstDash val="solid"/>
+          </a:ln>
+        </p:spPr>
+        <p:txBody>
+          <a:bodyPr xmlns:a="http://schemas.openxmlformats.org/drawingml/2006/main" wrap="square" lIns="0" tIns="0" rIns="0" bIns="0" anchor="t">
+            <a:normAutofit fontScale="100000"/>
+          </a:bodyPr>
+          <a:lstStyle xmlns:a="http://schemas.openxmlformats.org/drawingml/2006/main"/>
+          <a:p xmlns:a="http://schemas.openxmlformats.org/drawingml/2006/main">
+            <a:pPr algn="l">
+              <a:buNone/>
+              <a:defRPr sz="825" b="0">
+                <a:solidFill>
+                  <a:srgbClr val="64748B"/>
+                </a:solidFill>
+                <a:latin typeface="Arial"/>
+                <a:ea typeface="Arial"/>
+                <a:cs typeface="Arial"/>
+              </a:defRPr>
+            </a:pPr>
+            <a:r>
+              <a:rPr sz="825" b="0">
+                <a:solidFill>
+                  <a:srgbClr val="64748B"/>
+                </a:solidFill>
+                <a:latin typeface="Arial"/>
+                <a:ea typeface="Arial"/>
+                <a:cs typeface="Arial"/>
+              </a:rPr>
+              <a:t>Frozen current GICS labels | eight stocks per sector | 225 cells</a:t>
+            </a:r>
+          </a:p>
+        </p:txBody>
+      </p:sp>
+      <p:sp>
+        <p:nvSpPr>
+          <p:cNvPr id="5" name="footer-number-11">
+            <a:extLst xmlns:a="http://schemas.openxmlformats.org/drawingml/2006/main">
+              <a:ext uri="{FF2B5EF4-FFF2-40B4-BE49-F238E27FC236}">
+                <a16:creationId xmlns:a16="http://schemas.microsoft.com/office/drawing/2014/main" id="{83896276-4112-4532-AF7C-776C67C58B77}"/>
+              </a:ext>
+            </a:extLst>
+          </p:cNvPr>
+          <p:cNvSpPr>
+            <a:spLocks xmlns:a="http://schemas.openxmlformats.org/drawingml/2006/main" noGrp="1"/>
+          </p:cNvSpPr>
+          <p:nvPr/>
+        </p:nvSpPr>
+        <p:spPr>
+          <a:xfrm xmlns:a="http://schemas.openxmlformats.org/drawingml/2006/main">
+            <a:off x="10477500" y="6496050"/>
+            <a:ext cx="1257300" cy="190500"/>
+          </a:xfrm>
+          <a:prstGeom xmlns:a="http://schemas.openxmlformats.org/drawingml/2006/main" prst="rect">
+            <a:avLst/>
+          </a:prstGeom>
+          <a:noFill xmlns:a="http://schemas.openxmlformats.org/drawingml/2006/main"/>
+          <a:ln xmlns:a="http://schemas.openxmlformats.org/drawingml/2006/main" w="0">
+            <a:noFill/>
+            <a:prstDash val="solid"/>
+          </a:ln>
+        </p:spPr>
+        <p:txBody>
+          <a:bodyPr xmlns:a="http://schemas.openxmlformats.org/drawingml/2006/main" wrap="square" lIns="0" tIns="0" rIns="0" bIns="0" anchor="t">
+            <a:normAutofit fontScale="100000"/>
+          </a:bodyPr>
+          <a:lstStyle xmlns:a="http://schemas.openxmlformats.org/drawingml/2006/main"/>
+          <a:p xmlns:a="http://schemas.openxmlformats.org/drawingml/2006/main">
+            <a:pPr algn="r">
+              <a:buNone/>
+              <a:defRPr sz="1050" b="0">
+                <a:solidFill>
+                  <a:srgbClr val="667384"/>
+                </a:solidFill>
+                <a:latin typeface="Arial"/>
+                <a:ea typeface="Arial"/>
+                <a:cs typeface="Arial"/>
+              </a:defRPr>
+            </a:pPr>
+            <a:r>
+              <a:rPr sz="1050" b="0">
+                <a:solidFill>
+                  <a:srgbClr val="667384"/>
+                </a:solidFill>
+                <a:latin typeface="Arial"/>
+                <a:ea typeface="Arial"/>
+                <a:cs typeface="Arial"/>
+              </a:rPr>
+              <a:t>13</a:t>
+            </a:r>
+          </a:p>
+        </p:txBody>
+      </p:sp>
+      <p:pic>
+        <p:nvPicPr>
+          <p:cNvPr id="31" name=""/>
+          <p:cNvPicPr>
+            <a:picLocks xmlns:a="http://schemas.openxmlformats.org/drawingml/2006/main" noChangeAspect="1"/>
+          </p:cNvPicPr>
+          <p:nvPr/>
+        </p:nvPicPr>
+        <p:blipFill>
+          <a:blip xmlns:r="http://schemas.openxmlformats.org/officeDocument/2006/relationships" xmlns:a="http://schemas.openxmlformats.org/drawingml/2006/main" r:embed="R49713716ac59446d"/>
+          <a:stretch xmlns:a="http://schemas.openxmlformats.org/drawingml/2006/main"/>
+        </p:blipFill>
+        <p:spPr>
+          <a:xfrm xmlns:a="http://schemas.openxmlformats.org/drawingml/2006/main">
+            <a:off x="2885498" y="1847571"/>
+            <a:ext cx="6421005" cy="4020107"/>
+          </a:xfrm>
+          <a:prstGeom xmlns:a="http://schemas.openxmlformats.org/drawingml/2006/main" prst="rect">
+            <a:avLst/>
+          </a:prstGeom>
+        </p:spPr>
+      </p:pic>
+    </p:spTree>
+    <p:extLst>
+      <p:ext uri="{BB962C8B-B14F-4D97-AF65-F5344CB8AC3E}">
+        <p14:creationId xmlns:p14="http://schemas.microsoft.com/office/powerpoint/2010/main" val="666536286"/>
+      </p:ext>
+    </p:extLst>
+  </p:cSld>
+</p:sld>
+</file>
+
+<file path=ppt/slides/slide14.xml><?xml version="1.0" encoding="utf-8"?>
+<p:sld xmlns:p="http://schemas.openxmlformats.org/presentationml/2006/main">
+  <p:cSld>
+    <p:bg>
+      <p:bgPr>
+        <a:solidFill xmlns:a="http://schemas.openxmlformats.org/drawingml/2006/main">
+          <a:srgbClr val="FFFFFF"/>
+        </a:solidFill>
+      </p:bgPr>
+    </p:bg>
+    <p:spTree>
+      <p:nvGrpSpPr>
+        <p:cNvPr id="1" name=""/>
+        <p:cNvGrpSpPr/>
+        <p:nvPr/>
+      </p:nvGrpSpPr>
+      <p:grpSpPr>
+        <a:xfrm xmlns:a="http://schemas.openxmlformats.org/drawingml/2006/main"/>
+      </p:grpSpPr>
+      <p:sp>
+        <p:nvSpPr>
+          <p:cNvPr id="24" name="section-11">
+            <a:extLst xmlns:a="http://schemas.openxmlformats.org/drawingml/2006/main">
+              <a:ext uri="{FF2B5EF4-FFF2-40B4-BE49-F238E27FC236}">
+                <a16:creationId xmlns:a16="http://schemas.microsoft.com/office/drawing/2014/main" id="{272ED433-B59C-436C-9DFB-4D317B90A13F}"/>
+              </a:ext>
+            </a:extLst>
+          </p:cNvPr>
+          <p:cNvSpPr>
+            <a:spLocks xmlns:a="http://schemas.openxmlformats.org/drawingml/2006/main" noGrp="1"/>
+          </p:cNvSpPr>
+          <p:nvPr/>
+        </p:nvSpPr>
+        <p:spPr>
+          <a:xfrm xmlns:a="http://schemas.openxmlformats.org/drawingml/2006/main">
+            <a:off x="457200" y="228600"/>
+            <a:ext cx="4191000" cy="228600"/>
+          </a:xfrm>
+          <a:prstGeom xmlns:a="http://schemas.openxmlformats.org/drawingml/2006/main" prst="rect">
+            <a:avLst/>
+          </a:prstGeom>
+          <a:noFill xmlns:a="http://schemas.openxmlformats.org/drawingml/2006/main"/>
+          <a:ln xmlns:a="http://schemas.openxmlformats.org/drawingml/2006/main" w="0">
+            <a:noFill/>
+            <a:prstDash val="solid"/>
+          </a:ln>
+        </p:spPr>
+        <p:txBody>
+          <a:bodyPr xmlns:a="http://schemas.openxmlformats.org/drawingml/2006/main" wrap="square" lIns="0" tIns="0" rIns="0" bIns="0" anchor="t">
+            <a:normAutofit fontScale="100000"/>
+          </a:bodyPr>
+          <a:lstStyle xmlns:a="http://schemas.openxmlformats.org/drawingml/2006/main"/>
+          <a:p xmlns:a="http://schemas.openxmlformats.org/drawingml/2006/main">
+            <a:pPr algn="l">
+              <a:buNone/>
+              <a:defRPr sz="1200" b="1">
+                <a:solidFill>
+                  <a:srgbClr val="667384"/>
+                </a:solidFill>
+                <a:latin typeface="Arial"/>
+                <a:ea typeface="Arial"/>
+                <a:cs typeface="Arial"/>
+              </a:defRPr>
+            </a:pPr>
+            <a:r>
+              <a:rPr sz="1200" b="1">
+                <a:solidFill>
+                  <a:srgbClr val="667384"/>
+                </a:solidFill>
+                <a:latin typeface="Arial"/>
+                <a:ea typeface="Arial"/>
+                <a:cs typeface="Arial"/>
+              </a:rPr>
+              <a:t>EXCEPTIONS</a:t>
+            </a:r>
+          </a:p>
+        </p:txBody>
+      </p:sp>
+      <p:sp>
+        <p:nvSpPr>
+          <p:cNvPr id="2" name="title-11">
+            <a:extLst xmlns:a="http://schemas.openxmlformats.org/drawingml/2006/main">
+              <a:ext uri="{FF2B5EF4-FFF2-40B4-BE49-F238E27FC236}">
+                <a16:creationId xmlns:a16="http://schemas.microsoft.com/office/drawing/2014/main" id="{3EC40708-7E00-432C-8ECE-907FA5705292}"/>
+              </a:ext>
+            </a:extLst>
+          </p:cNvPr>
+          <p:cNvSpPr>
+            <a:spLocks xmlns:a="http://schemas.openxmlformats.org/drawingml/2006/main" noGrp="1"/>
+          </p:cNvSpPr>
+          <p:nvPr/>
+        </p:nvSpPr>
+        <p:spPr>
+          <a:xfrm xmlns:a="http://schemas.openxmlformats.org/drawingml/2006/main">
+            <a:off x="457200" y="533400"/>
+            <a:ext cx="11277600" cy="628650"/>
+          </a:xfrm>
+          <a:prstGeom xmlns:a="http://schemas.openxmlformats.org/drawingml/2006/main" prst="rect">
+            <a:avLst/>
+          </a:prstGeom>
+          <a:noFill xmlns:a="http://schemas.openxmlformats.org/drawingml/2006/main"/>
+          <a:ln xmlns:a="http://schemas.openxmlformats.org/drawingml/2006/main" w="0">
+            <a:noFill/>
+            <a:prstDash val="solid"/>
+          </a:ln>
+        </p:spPr>
+        <p:txBody>
+          <a:bodyPr xmlns:a="http://schemas.openxmlformats.org/drawingml/2006/main" wrap="square" lIns="0" tIns="0" rIns="0" bIns="0" anchor="t">
+            <a:normAutofit fontScale="100000"/>
+          </a:bodyPr>
+          <a:lstStyle xmlns:a="http://schemas.openxmlformats.org/drawingml/2006/main"/>
+          <a:p xmlns:a="http://schemas.openxmlformats.org/drawingml/2006/main">
+            <a:pPr algn="l">
+              <a:buNone/>
+              <a:defRPr sz="3525" b="1">
+                <a:solidFill>
+                  <a:srgbClr val="000000"/>
+                </a:solidFill>
+                <a:latin typeface="Arial"/>
+                <a:ea typeface="Arial"/>
+                <a:cs typeface="Arial"/>
+              </a:defRPr>
+            </a:pPr>
+            <a:r>
+              <a:rPr sz="3525" b="1">
+                <a:solidFill>
+                  <a:srgbClr val="000000"/>
+                </a:solidFill>
+                <a:latin typeface="Arial"/>
+                <a:ea typeface="Arial"/>
+                <a:cs typeface="Arial"/>
+              </a:rPr>
+              <a:t>The state contrast has clear exceptions</a:t>
+            </a:r>
+          </a:p>
+        </p:txBody>
+      </p:sp>
+      <p:sp>
+        <p:nvSpPr>
+          <p:cNvPr id="3" name="">
+            <a:extLst xmlns:a="http://schemas.openxmlformats.org/drawingml/2006/main">
+              <a:ext uri="{FF2B5EF4-FFF2-40B4-BE49-F238E27FC236}">
+                <a16:creationId xmlns:a16="http://schemas.microsoft.com/office/drawing/2014/main" id="{D5CA0FCE-75E8-41EF-A76A-23E9E2120C6A}"/>
+              </a:ext>
+            </a:extLst>
+          </p:cNvPr>
+          <p:cNvSpPr>
+            <a:spLocks xmlns:a="http://schemas.openxmlformats.org/drawingml/2006/main" noGrp="1"/>
+          </p:cNvSpPr>
+          <p:nvPr/>
+        </p:nvSpPr>
+        <p:spPr>
+          <a:xfrm xmlns:a="http://schemas.openxmlformats.org/drawingml/2006/main">
+            <a:off x="457200" y="1200150"/>
+            <a:ext cx="11277600" cy="19050"/>
+          </a:xfrm>
+          <a:prstGeom xmlns:a="http://schemas.openxmlformats.org/drawingml/2006/main" prst="rect">
+            <a:avLst/>
+          </a:prstGeom>
+          <a:solidFill xmlns:a="http://schemas.openxmlformats.org/drawingml/2006/main">
+            <a:srgbClr val="B8BCC4"/>
+          </a:solidFill>
+          <a:ln xmlns:a="http://schemas.openxmlformats.org/drawingml/2006/main" w="0">
+            <a:solidFill>
+              <a:srgbClr val="B8BCC4"/>
+            </a:solidFill>
+            <a:prstDash val="solid"/>
+          </a:ln>
+        </p:spPr>
+      </p:sp>
+      <p:sp>
+        <p:nvSpPr>
+          <p:cNvPr id="4" name="footer-left-11">
+            <a:extLst xmlns:a="http://schemas.openxmlformats.org/drawingml/2006/main">
+              <a:ext uri="{FF2B5EF4-FFF2-40B4-BE49-F238E27FC236}">
+                <a16:creationId xmlns:a16="http://schemas.microsoft.com/office/drawing/2014/main" id="{700DA765-80E0-4197-8700-00D867B86FA2}"/>
+              </a:ext>
+            </a:extLst>
+          </p:cNvPr>
+          <p:cNvSpPr>
+            <a:spLocks xmlns:a="http://schemas.openxmlformats.org/drawingml/2006/main" noGrp="1"/>
+          </p:cNvSpPr>
+          <p:nvPr/>
+        </p:nvSpPr>
+        <p:spPr>
+          <a:xfrm xmlns:a="http://schemas.openxmlformats.org/drawingml/2006/main">
+            <a:off x="457200" y="6515100"/>
+            <a:ext cx="3429000" cy="171450"/>
+          </a:xfrm>
+          <a:prstGeom xmlns:a="http://schemas.openxmlformats.org/drawingml/2006/main" prst="rect">
+            <a:avLst/>
+          </a:prstGeom>
+          <a:noFill xmlns:a="http://schemas.openxmlformats.org/drawingml/2006/main"/>
+          <a:ln xmlns:a="http://schemas.openxmlformats.org/drawingml/2006/main" w="0">
+            <a:noFill/>
+            <a:prstDash val="solid"/>
+          </a:ln>
+        </p:spPr>
+        <p:txBody>
+          <a:bodyPr xmlns:a="http://schemas.openxmlformats.org/drawingml/2006/main" wrap="square" lIns="0" tIns="0" rIns="0" bIns="0" anchor="t">
+            <a:normAutofit fontScale="100000"/>
+          </a:bodyPr>
+          <a:lstStyle xmlns:a="http://schemas.openxmlformats.org/drawingml/2006/main"/>
+          <a:p xmlns:a="http://schemas.openxmlformats.org/drawingml/2006/main">
+            <a:pPr algn="l">
+              <a:buNone/>
+              <a:defRPr sz="825" b="0">
+                <a:solidFill>
+                  <a:srgbClr val="64748B"/>
+                </a:solidFill>
+                <a:latin typeface="Arial"/>
+                <a:ea typeface="Arial"/>
+                <a:cs typeface="Arial"/>
+              </a:defRPr>
+            </a:pPr>
+            <a:r>
+              <a:rPr sz="825" b="0">
+                <a:solidFill>
+                  <a:srgbClr val="64748B"/>
+                </a:solidFill>
+                <a:latin typeface="Arial"/>
+                <a:ea typeface="Arial"/>
+                <a:cs typeface="Arial"/>
+              </a:rPr>
+              <a:t>Equal-horizon diagonal | context for non-uniformity | no cell selection</a:t>
+            </a:r>
+          </a:p>
+        </p:txBody>
+      </p:sp>
+      <p:sp>
+        <p:nvSpPr>
+          <p:cNvPr id="5" name="footer-number-11">
+            <a:extLst xmlns:a="http://schemas.openxmlformats.org/drawingml/2006/main">
+              <a:ext uri="{FF2B5EF4-FFF2-40B4-BE49-F238E27FC236}">
+                <a16:creationId xmlns:a16="http://schemas.microsoft.com/office/drawing/2014/main" id="{83896276-4112-4532-AF7C-776C67C58B77}"/>
+              </a:ext>
+            </a:extLst>
+          </p:cNvPr>
+          <p:cNvSpPr>
+            <a:spLocks xmlns:a="http://schemas.openxmlformats.org/drawingml/2006/main" noGrp="1"/>
+          </p:cNvSpPr>
+          <p:nvPr/>
+        </p:nvSpPr>
+        <p:spPr>
+          <a:xfrm xmlns:a="http://schemas.openxmlformats.org/drawingml/2006/main">
+            <a:off x="10477500" y="6496050"/>
+            <a:ext cx="1257300" cy="190500"/>
+          </a:xfrm>
+          <a:prstGeom xmlns:a="http://schemas.openxmlformats.org/drawingml/2006/main" prst="rect">
+            <a:avLst/>
+          </a:prstGeom>
+          <a:noFill xmlns:a="http://schemas.openxmlformats.org/drawingml/2006/main"/>
+          <a:ln xmlns:a="http://schemas.openxmlformats.org/drawingml/2006/main" w="0">
+            <a:noFill/>
+            <a:prstDash val="solid"/>
+          </a:ln>
+        </p:spPr>
+        <p:txBody>
+          <a:bodyPr xmlns:a="http://schemas.openxmlformats.org/drawingml/2006/main" wrap="square" lIns="0" tIns="0" rIns="0" bIns="0" anchor="t">
+            <a:normAutofit fontScale="100000"/>
+          </a:bodyPr>
+          <a:lstStyle xmlns:a="http://schemas.openxmlformats.org/drawingml/2006/main"/>
+          <a:p xmlns:a="http://schemas.openxmlformats.org/drawingml/2006/main">
+            <a:pPr algn="r">
+              <a:buNone/>
+              <a:defRPr sz="1050" b="0">
+                <a:solidFill>
+                  <a:srgbClr val="667384"/>
+                </a:solidFill>
+                <a:latin typeface="Arial"/>
+                <a:ea typeface="Arial"/>
+                <a:cs typeface="Arial"/>
+              </a:defRPr>
+            </a:pPr>
+            <a:r>
+              <a:rPr sz="1050" b="0">
+                <a:solidFill>
+                  <a:srgbClr val="667384"/>
+                </a:solidFill>
+                <a:latin typeface="Arial"/>
+                <a:ea typeface="Arial"/>
+                <a:cs typeface="Arial"/>
+              </a:rPr>
+              <a:t>14</a:t>
+            </a:r>
+          </a:p>
+        </p:txBody>
+      </p:sp>
+      <p:pic>
+        <p:nvPicPr>
+          <p:cNvPr id="31" name=""/>
+          <p:cNvPicPr>
+            <a:picLocks xmlns:a="http://schemas.openxmlformats.org/drawingml/2006/main" noChangeAspect="1"/>
+          </p:cNvPicPr>
+          <p:nvPr/>
+        </p:nvPicPr>
+        <p:blipFill>
+          <a:blip xmlns:r="http://schemas.openxmlformats.org/officeDocument/2006/relationships" xmlns:a="http://schemas.openxmlformats.org/drawingml/2006/main" r:embed="Rcbdfc70cd8724c43"/>
+          <a:stretch xmlns:a="http://schemas.openxmlformats.org/drawingml/2006/main"/>
+        </p:blipFill>
+        <p:spPr>
+          <a:xfrm xmlns:a="http://schemas.openxmlformats.org/drawingml/2006/main">
+            <a:off x="2885498" y="2042993"/>
+            <a:ext cx="6421005" cy="3629264"/>
+          </a:xfrm>
+          <a:prstGeom xmlns:a="http://schemas.openxmlformats.org/drawingml/2006/main" prst="rect">
+            <a:avLst/>
+          </a:prstGeom>
+        </p:spPr>
+      </p:pic>
+    </p:spTree>
+    <p:extLst>
+      <p:ext uri="{BB962C8B-B14F-4D97-AF65-F5344CB8AC3E}">
+        <p14:creationId xmlns:p14="http://schemas.microsoft.com/office/powerpoint/2010/main" val="666536286"/>
+      </p:ext>
+    </p:extLst>
+  </p:cSld>
+</p:sld>
+</file>
+
+<file path=ppt/slides/slide15.xml><?xml version="1.0" encoding="utf-8"?>
+<p:sld xmlns:p="http://schemas.openxmlformats.org/presentationml/2006/main">
+  <p:cSld>
+    <p:bg>
+      <p:bgPr>
+        <a:solidFill xmlns:a="http://schemas.openxmlformats.org/drawingml/2006/main">
+          <a:srgbClr val="FFFFFF"/>
+        </a:solidFill>
+      </p:bgPr>
+    </p:bg>
+    <p:spTree>
+      <p:nvGrpSpPr>
+        <p:cNvPr id="1" name=""/>
+        <p:cNvGrpSpPr/>
+        <p:nvPr/>
+      </p:nvGrpSpPr>
+      <p:grpSpPr>
+        <a:xfrm xmlns:a="http://schemas.openxmlformats.org/drawingml/2006/main"/>
+      </p:grpSpPr>
+      <p:sp>
+        <p:nvSpPr>
+          <p:cNvPr id="24" name="section-11">
+            <a:extLst xmlns:a="http://schemas.openxmlformats.org/drawingml/2006/main">
+              <a:ext uri="{FF2B5EF4-FFF2-40B4-BE49-F238E27FC236}">
+                <a16:creationId xmlns:a16="http://schemas.microsoft.com/office/drawing/2014/main" id="{272ED433-B59C-436C-9DFB-4D317B90A13F}"/>
+              </a:ext>
+            </a:extLst>
+          </p:cNvPr>
+          <p:cNvSpPr>
+            <a:spLocks xmlns:a="http://schemas.openxmlformats.org/drawingml/2006/main" noGrp="1"/>
+          </p:cNvSpPr>
+          <p:nvPr/>
+        </p:nvSpPr>
+        <p:spPr>
+          <a:xfrm xmlns:a="http://schemas.openxmlformats.org/drawingml/2006/main">
+            <a:off x="457200" y="228600"/>
+            <a:ext cx="4191000" cy="228600"/>
+          </a:xfrm>
+          <a:prstGeom xmlns:a="http://schemas.openxmlformats.org/drawingml/2006/main" prst="rect">
+            <a:avLst/>
+          </a:prstGeom>
+          <a:noFill xmlns:a="http://schemas.openxmlformats.org/drawingml/2006/main"/>
+          <a:ln xmlns:a="http://schemas.openxmlformats.org/drawingml/2006/main" w="0">
+            <a:noFill/>
+            <a:prstDash val="solid"/>
+          </a:ln>
+        </p:spPr>
+        <p:txBody>
+          <a:bodyPr xmlns:a="http://schemas.openxmlformats.org/drawingml/2006/main" wrap="square" lIns="0" tIns="0" rIns="0" bIns="0" anchor="t">
+            <a:normAutofit fontScale="100000"/>
+          </a:bodyPr>
+          <a:lstStyle xmlns:a="http://schemas.openxmlformats.org/drawingml/2006/main"/>
+          <a:p xmlns:a="http://schemas.openxmlformats.org/drawingml/2006/main">
+            <a:pPr algn="l">
+              <a:buNone/>
+              <a:defRPr sz="1200" b="1">
+                <a:solidFill>
+                  <a:srgbClr val="667384"/>
+                </a:solidFill>
+                <a:latin typeface="Arial"/>
+                <a:ea typeface="Arial"/>
+                <a:cs typeface="Arial"/>
+              </a:defRPr>
+            </a:pPr>
+            <a:r>
+              <a:rPr sz="1200" b="1">
+                <a:solidFill>
+                  <a:srgbClr val="667384"/>
+                </a:solidFill>
+                <a:latin typeface="Arial"/>
+                <a:ea typeface="Arial"/>
+                <a:cs typeface="Arial"/>
+              </a:rPr>
+              <a:t>CONTRAST READOUT</a:t>
+            </a:r>
+          </a:p>
+        </p:txBody>
+      </p:sp>
+      <p:sp>
+        <p:nvSpPr>
+          <p:cNvPr id="2" name="title-11">
+            <a:extLst xmlns:a="http://schemas.openxmlformats.org/drawingml/2006/main">
+              <a:ext uri="{FF2B5EF4-FFF2-40B4-BE49-F238E27FC236}">
+                <a16:creationId xmlns:a16="http://schemas.microsoft.com/office/drawing/2014/main" id="{3EC40708-7E00-432C-8ECE-907FA5705292}"/>
+              </a:ext>
+            </a:extLst>
+          </p:cNvPr>
+          <p:cNvSpPr>
+            <a:spLocks xmlns:a="http://schemas.openxmlformats.org/drawingml/2006/main" noGrp="1"/>
+          </p:cNvSpPr>
+          <p:nvPr/>
+        </p:nvSpPr>
+        <p:spPr>
+          <a:xfrm xmlns:a="http://schemas.openxmlformats.org/drawingml/2006/main">
+            <a:off x="457200" y="533400"/>
+            <a:ext cx="11277600" cy="628650"/>
+          </a:xfrm>
+          <a:prstGeom xmlns:a="http://schemas.openxmlformats.org/drawingml/2006/main" prst="rect">
+            <a:avLst/>
+          </a:prstGeom>
+          <a:noFill xmlns:a="http://schemas.openxmlformats.org/drawingml/2006/main"/>
+          <a:ln xmlns:a="http://schemas.openxmlformats.org/drawingml/2006/main" w="0">
+            <a:noFill/>
+            <a:prstDash val="solid"/>
+          </a:ln>
+        </p:spPr>
+        <p:txBody>
+          <a:bodyPr xmlns:a="http://schemas.openxmlformats.org/drawingml/2006/main" wrap="square" lIns="0" tIns="0" rIns="0" bIns="0" anchor="t">
+            <a:normAutofit fontScale="100000"/>
+          </a:bodyPr>
+          <a:lstStyle xmlns:a="http://schemas.openxmlformats.org/drawingml/2006/main"/>
+          <a:p xmlns:a="http://schemas.openxmlformats.org/drawingml/2006/main">
+            <a:pPr algn="l">
+              <a:buNone/>
+              <a:defRPr sz="3525" b="1">
+                <a:solidFill>
+                  <a:srgbClr val="000000"/>
+                </a:solidFill>
+                <a:latin typeface="Arial"/>
+                <a:ea typeface="Arial"/>
+                <a:cs typeface="Arial"/>
+              </a:defRPr>
+            </a:pPr>
+            <a:r>
+              <a:rPr sz="3525" b="1">
+                <a:solidFill>
+                  <a:srgbClr val="000000"/>
+                </a:solidFill>
+                <a:latin typeface="Arial"/>
+                <a:ea typeface="Arial"/>
+                <a:cs typeface="Arial"/>
+              </a:rPr>
+              <a:t>The state discriminator is broad but still descriptive</a:t>
+            </a:r>
+          </a:p>
+        </p:txBody>
+      </p:sp>
+      <p:sp>
+        <p:nvSpPr>
+          <p:cNvPr id="3" name="">
+            <a:extLst xmlns:a="http://schemas.openxmlformats.org/drawingml/2006/main">
+              <a:ext uri="{FF2B5EF4-FFF2-40B4-BE49-F238E27FC236}">
+                <a16:creationId xmlns:a16="http://schemas.microsoft.com/office/drawing/2014/main" id="{D5CA0FCE-75E8-41EF-A76A-23E9E2120C6A}"/>
+              </a:ext>
+            </a:extLst>
+          </p:cNvPr>
+          <p:cNvSpPr>
+            <a:spLocks xmlns:a="http://schemas.openxmlformats.org/drawingml/2006/main" noGrp="1"/>
+          </p:cNvSpPr>
+          <p:nvPr/>
+        </p:nvSpPr>
+        <p:spPr>
+          <a:xfrm xmlns:a="http://schemas.openxmlformats.org/drawingml/2006/main">
+            <a:off x="457200" y="1200150"/>
+            <a:ext cx="11277600" cy="19050"/>
+          </a:xfrm>
+          <a:prstGeom xmlns:a="http://schemas.openxmlformats.org/drawingml/2006/main" prst="rect">
+            <a:avLst/>
+          </a:prstGeom>
+          <a:solidFill xmlns:a="http://schemas.openxmlformats.org/drawingml/2006/main">
+            <a:srgbClr val="B8BCC4"/>
+          </a:solidFill>
+          <a:ln xmlns:a="http://schemas.openxmlformats.org/drawingml/2006/main" w="0">
+            <a:solidFill>
+              <a:srgbClr val="B8BCC4"/>
+            </a:solidFill>
+            <a:prstDash val="solid"/>
+          </a:ln>
+        </p:spPr>
+      </p:sp>
+      <p:sp>
+        <p:nvSpPr>
+          <p:cNvPr id="4" name="footer-left-11">
+            <a:extLst xmlns:a="http://schemas.openxmlformats.org/drawingml/2006/main">
+              <a:ext uri="{FF2B5EF4-FFF2-40B4-BE49-F238E27FC236}">
+                <a16:creationId xmlns:a16="http://schemas.microsoft.com/office/drawing/2014/main" id="{700DA765-80E0-4197-8700-00D867B86FA2}"/>
+              </a:ext>
+            </a:extLst>
+          </p:cNvPr>
+          <p:cNvSpPr>
+            <a:spLocks xmlns:a="http://schemas.openxmlformats.org/drawingml/2006/main" noGrp="1"/>
+          </p:cNvSpPr>
+          <p:nvPr/>
+        </p:nvSpPr>
+        <p:spPr>
+          <a:xfrm xmlns:a="http://schemas.openxmlformats.org/drawingml/2006/main">
+            <a:off x="457200" y="6515100"/>
+            <a:ext cx="3429000" cy="171450"/>
+          </a:xfrm>
+          <a:prstGeom xmlns:a="http://schemas.openxmlformats.org/drawingml/2006/main" prst="rect">
+            <a:avLst/>
+          </a:prstGeom>
+          <a:noFill xmlns:a="http://schemas.openxmlformats.org/drawingml/2006/main"/>
+          <a:ln xmlns:a="http://schemas.openxmlformats.org/drawingml/2006/main" w="0">
+            <a:noFill/>
+            <a:prstDash val="solid"/>
+          </a:ln>
+        </p:spPr>
+        <p:txBody>
+          <a:bodyPr xmlns:a="http://schemas.openxmlformats.org/drawingml/2006/main" wrap="square" lIns="0" tIns="0" rIns="0" bIns="0" anchor="t">
+            <a:normAutofit fontScale="100000"/>
+          </a:bodyPr>
+          <a:lstStyle xmlns:a="http://schemas.openxmlformats.org/drawingml/2006/main"/>
+          <a:p xmlns:a="http://schemas.openxmlformats.org/drawingml/2006/main">
+            <a:pPr algn="l">
+              <a:buNone/>
+              <a:defRPr sz="825" b="0">
+                <a:solidFill>
+                  <a:srgbClr val="64748B"/>
+                </a:solidFill>
+                <a:latin typeface="Arial"/>
+                <a:ea typeface="Arial"/>
+                <a:cs typeface="Arial"/>
+              </a:defRPr>
+            </a:pPr>
+            <a:r>
+              <a:rPr sz="825" b="0">
+                <a:solidFill>
+                  <a:srgbClr val="64748B"/>
+                </a:solidFill>
+                <a:latin typeface="Arial"/>
+                <a:ea typeface="Arial"/>
+                <a:cs typeface="Arial"/>
+              </a:rPr>
+              <a:t>Return geometry | ER20 state contrast | 2018–2023</a:t>
+            </a:r>
+          </a:p>
+        </p:txBody>
+      </p:sp>
+      <p:sp>
+        <p:nvSpPr>
+          <p:cNvPr id="5" name="footer-number-11">
+            <a:extLst xmlns:a="http://schemas.openxmlformats.org/drawingml/2006/main">
+              <a:ext uri="{FF2B5EF4-FFF2-40B4-BE49-F238E27FC236}">
+                <a16:creationId xmlns:a16="http://schemas.microsoft.com/office/drawing/2014/main" id="{83896276-4112-4532-AF7C-776C67C58B77}"/>
+              </a:ext>
+            </a:extLst>
+          </p:cNvPr>
+          <p:cNvSpPr>
+            <a:spLocks xmlns:a="http://schemas.openxmlformats.org/drawingml/2006/main" noGrp="1"/>
+          </p:cNvSpPr>
+          <p:nvPr/>
+        </p:nvSpPr>
+        <p:spPr>
+          <a:xfrm xmlns:a="http://schemas.openxmlformats.org/drawingml/2006/main">
+            <a:off x="10477500" y="6496050"/>
+            <a:ext cx="1257300" cy="190500"/>
+          </a:xfrm>
+          <a:prstGeom xmlns:a="http://schemas.openxmlformats.org/drawingml/2006/main" prst="rect">
+            <a:avLst/>
+          </a:prstGeom>
+          <a:noFill xmlns:a="http://schemas.openxmlformats.org/drawingml/2006/main"/>
+          <a:ln xmlns:a="http://schemas.openxmlformats.org/drawingml/2006/main" w="0">
+            <a:noFill/>
+            <a:prstDash val="solid"/>
+          </a:ln>
+        </p:spPr>
+        <p:txBody>
+          <a:bodyPr xmlns:a="http://schemas.openxmlformats.org/drawingml/2006/main" wrap="square" lIns="0" tIns="0" rIns="0" bIns="0" anchor="t">
+            <a:normAutofit fontScale="100000"/>
+          </a:bodyPr>
+          <a:lstStyle xmlns:a="http://schemas.openxmlformats.org/drawingml/2006/main"/>
+          <a:p xmlns:a="http://schemas.openxmlformats.org/drawingml/2006/main">
+            <a:pPr algn="r">
+              <a:buNone/>
+              <a:defRPr sz="1050" b="0">
+                <a:solidFill>
+                  <a:srgbClr val="667384"/>
+                </a:solidFill>
+                <a:latin typeface="Arial"/>
+                <a:ea typeface="Arial"/>
+                <a:cs typeface="Arial"/>
+              </a:defRPr>
+            </a:pPr>
+            <a:r>
+              <a:rPr sz="1050" b="0">
+                <a:solidFill>
+                  <a:srgbClr val="667384"/>
+                </a:solidFill>
+                <a:latin typeface="Arial"/>
+                <a:ea typeface="Arial"/>
+                <a:cs typeface="Arial"/>
+              </a:rPr>
+              <a:t>15</a:t>
+            </a:r>
+          </a:p>
+        </p:txBody>
+      </p:sp>
+      <p:sp>
+        <p:nvSpPr>
+          <p:cNvPr id="6" name="">
+            <a:extLst xmlns:a="http://schemas.openxmlformats.org/drawingml/2006/main">
+              <a:ext uri="{FF2B5EF4-FFF2-40B4-BE49-F238E27FC236}">
+                <a16:creationId xmlns:a16="http://schemas.microsoft.com/office/drawing/2014/main" id="{10F4BA85-46C5-47BD-BA74-EC806E663D58}"/>
+              </a:ext>
+            </a:extLst>
+          </p:cNvPr>
+          <p:cNvSpPr>
+            <a:spLocks xmlns:a="http://schemas.openxmlformats.org/drawingml/2006/main" noGrp="1"/>
+          </p:cNvSpPr>
+          <p:nvPr/>
+        </p:nvSpPr>
+        <p:spPr>
+          <a:xfrm xmlns:a="http://schemas.openxmlformats.org/drawingml/2006/main">
+            <a:off x="552450" y="1600200"/>
+            <a:ext cx="95250" cy="895350"/>
+          </a:xfrm>
+          <a:prstGeom xmlns:a="http://schemas.openxmlformats.org/drawingml/2006/main" prst="rect">
+            <a:avLst/>
+          </a:prstGeom>
+          <a:solidFill xmlns:a="http://schemas.openxmlformats.org/drawingml/2006/main">
+            <a:srgbClr val="E45756"/>
+          </a:solidFill>
+          <a:ln xmlns:a="http://schemas.openxmlformats.org/drawingml/2006/main" w="0">
+            <a:solidFill>
+              <a:srgbClr val="E45756"/>
+            </a:solidFill>
+            <a:prstDash val="solid"/>
+          </a:ln>
+        </p:spPr>
+      </p:sp>
+      <p:sp>
+        <p:nvSpPr>
+          <p:cNvPr id="7" name="">
+            <a:extLst xmlns:a="http://schemas.openxmlformats.org/drawingml/2006/main">
+              <a:ext uri="{FF2B5EF4-FFF2-40B4-BE49-F238E27FC236}">
+                <a16:creationId xmlns:a16="http://schemas.microsoft.com/office/drawing/2014/main" id="{7EF5B945-9D04-48FA-BA66-96DE813A9715}"/>
+              </a:ext>
+            </a:extLst>
+          </p:cNvPr>
+          <p:cNvSpPr>
+            <a:spLocks xmlns:a="http://schemas.openxmlformats.org/drawingml/2006/main" noGrp="1"/>
+          </p:cNvSpPr>
+          <p:nvPr/>
+        </p:nvSpPr>
+        <p:spPr>
+          <a:xfrm xmlns:a="http://schemas.openxmlformats.org/drawingml/2006/main">
+            <a:off x="876300" y="1581150"/>
+            <a:ext cx="2095500" cy="285750"/>
+          </a:xfrm>
+          <a:prstGeom xmlns:a="http://schemas.openxmlformats.org/drawingml/2006/main" prst="rect">
+            <a:avLst/>
+          </a:prstGeom>
+          <a:noFill xmlns:a="http://schemas.openxmlformats.org/drawingml/2006/main"/>
+          <a:ln xmlns:a="http://schemas.openxmlformats.org/drawingml/2006/main" w="0">
+            <a:noFill/>
+            <a:prstDash val="solid"/>
+          </a:ln>
+        </p:spPr>
+        <p:txBody>
+          <a:bodyPr xmlns:a="http://schemas.openxmlformats.org/drawingml/2006/main" wrap="square" lIns="0" tIns="0" rIns="0" bIns="0" anchor="t">
+            <a:normAutofit fontScale="100000"/>
+          </a:bodyPr>
+          <a:lstStyle xmlns:a="http://schemas.openxmlformats.org/drawingml/2006/main"/>
+          <a:p xmlns:a="http://schemas.openxmlformats.org/drawingml/2006/main">
+            <a:pPr algn="l">
+              <a:buNone/>
+              <a:defRPr sz="1350" b="1">
+                <a:solidFill>
+                  <a:srgbClr val="E45756"/>
+                </a:solidFill>
+                <a:latin typeface="Arial"/>
+                <a:ea typeface="Arial"/>
+                <a:cs typeface="Arial"/>
+              </a:defRPr>
+            </a:pPr>
+            <a:r>
+              <a:rPr sz="1350" b="1">
+                <a:solidFill>
+                  <a:srgbClr val="E45756"/>
+                </a:solidFill>
+                <a:latin typeface="Arial"/>
+                <a:ea typeface="Arial"/>
+                <a:cs typeface="Arial"/>
+              </a:rPr>
+              <a:t>SURFACE</a:t>
+            </a:r>
+          </a:p>
+        </p:txBody>
+      </p:sp>
+      <p:sp>
+        <p:nvSpPr>
+          <p:cNvPr id="8" name="">
+            <a:extLst xmlns:a="http://schemas.openxmlformats.org/drawingml/2006/main">
+              <a:ext uri="{FF2B5EF4-FFF2-40B4-BE49-F238E27FC236}">
+                <a16:creationId xmlns:a16="http://schemas.microsoft.com/office/drawing/2014/main" id="{655CF75D-5F23-4C7F-BE9C-764036D0B9E8}"/>
+              </a:ext>
+            </a:extLst>
+          </p:cNvPr>
+          <p:cNvSpPr>
+            <a:spLocks xmlns:a="http://schemas.openxmlformats.org/drawingml/2006/main" noGrp="1"/>
+          </p:cNvSpPr>
+          <p:nvPr/>
+        </p:nvSpPr>
+        <p:spPr>
+          <a:xfrm xmlns:a="http://schemas.openxmlformats.org/drawingml/2006/main">
+            <a:off x="3105150" y="1562100"/>
+            <a:ext cx="4762500" cy="419100"/>
+          </a:xfrm>
+          <a:prstGeom xmlns:a="http://schemas.openxmlformats.org/drawingml/2006/main" prst="rect">
+            <a:avLst/>
+          </a:prstGeom>
+          <a:noFill xmlns:a="http://schemas.openxmlformats.org/drawingml/2006/main"/>
+          <a:ln xmlns:a="http://schemas.openxmlformats.org/drawingml/2006/main" w="0">
+            <a:noFill/>
+            <a:prstDash val="solid"/>
+          </a:ln>
+        </p:spPr>
+        <p:txBody>
+          <a:bodyPr xmlns:a="http://schemas.openxmlformats.org/drawingml/2006/main" wrap="square" lIns="0" tIns="0" rIns="0" bIns="0" anchor="t">
+            <a:normAutofit fontScale="100000"/>
+          </a:bodyPr>
+          <a:lstStyle xmlns:a="http://schemas.openxmlformats.org/drawingml/2006/main"/>
+          <a:p xmlns:a="http://schemas.openxmlformats.org/drawingml/2006/main">
+            <a:pPr algn="l">
+              <a:buNone/>
+              <a:defRPr sz="1950" b="1">
+                <a:solidFill>
+                  <a:srgbClr val="273548"/>
+                </a:solidFill>
+                <a:latin typeface="Arial"/>
+                <a:ea typeface="Arial"/>
+                <a:cs typeface="Arial"/>
+              </a:defRPr>
+            </a:pPr>
+            <a:r>
+              <a:rPr sz="1950" b="1">
+                <a:solidFill>
+                  <a:srgbClr val="273548"/>
+                </a:solidFill>
+                <a:latin typeface="Arial"/>
+                <a:ea typeface="Arial"/>
+                <a:cs typeface="Arial"/>
+              </a:rPr>
+              <a:t>Paired median contrast</a:t>
+            </a:r>
+          </a:p>
+        </p:txBody>
+      </p:sp>
+      <p:sp>
+        <p:nvSpPr>
+          <p:cNvPr id="9" name="">
+            <a:extLst xmlns:a="http://schemas.openxmlformats.org/drawingml/2006/main">
+              <a:ext uri="{FF2B5EF4-FFF2-40B4-BE49-F238E27FC236}">
+                <a16:creationId xmlns:a16="http://schemas.microsoft.com/office/drawing/2014/main" id="{3E0B76F2-4514-4DD8-934B-ABE42A34E950}"/>
+              </a:ext>
+            </a:extLst>
+          </p:cNvPr>
+          <p:cNvSpPr>
+            <a:spLocks xmlns:a="http://schemas.openxmlformats.org/drawingml/2006/main" noGrp="1"/>
+          </p:cNvSpPr>
+          <p:nvPr/>
+        </p:nvSpPr>
+        <p:spPr>
+          <a:xfrm xmlns:a="http://schemas.openxmlformats.org/drawingml/2006/main">
+            <a:off x="8096250" y="1581150"/>
+            <a:ext cx="3333750" cy="704850"/>
+          </a:xfrm>
+          <a:prstGeom xmlns:a="http://schemas.openxmlformats.org/drawingml/2006/main" prst="rect">
+            <a:avLst/>
+          </a:prstGeom>
+          <a:noFill xmlns:a="http://schemas.openxmlformats.org/drawingml/2006/main"/>
+          <a:ln xmlns:a="http://schemas.openxmlformats.org/drawingml/2006/main" w="0">
+            <a:noFill/>
+            <a:prstDash val="solid"/>
+          </a:ln>
+        </p:spPr>
+        <p:txBody>
+          <a:bodyPr xmlns:a="http://schemas.openxmlformats.org/drawingml/2006/main" wrap="square" lIns="0" tIns="0" rIns="0" bIns="0" anchor="t">
+            <a:normAutofit fontScale="100000"/>
+          </a:bodyPr>
+          <a:lstStyle xmlns:a="http://schemas.openxmlformats.org/drawingml/2006/main"/>
+          <a:p xmlns:a="http://schemas.openxmlformats.org/drawingml/2006/main">
+            <a:pPr algn="l">
+              <a:buNone/>
+              <a:defRPr sz="1425" b="0">
+                <a:solidFill>
+                  <a:srgbClr val="667384"/>
+                </a:solidFill>
+                <a:latin typeface="Arial"/>
+                <a:ea typeface="Arial"/>
+                <a:cs typeface="Arial"/>
+              </a:defRPr>
+            </a:pPr>
+            <a:r>
+              <a:rPr sz="1425" b="0">
+                <a:solidFill>
+                  <a:srgbClr val="667384"/>
+                </a:solidFill>
+                <a:latin typeface="Arial"/>
+                <a:ea typeface="Arial"/>
+                <a:cs typeface="Arial"/>
+              </a:rPr>
+              <a:t>+0.048; 92.9% of cells positive</a:t>
+            </a:r>
+          </a:p>
+        </p:txBody>
+      </p:sp>
+      <p:sp>
+        <p:nvSpPr>
+          <p:cNvPr id="10" name="">
+            <a:extLst xmlns:a="http://schemas.openxmlformats.org/drawingml/2006/main">
+              <a:ext uri="{FF2B5EF4-FFF2-40B4-BE49-F238E27FC236}">
+                <a16:creationId xmlns:a16="http://schemas.microsoft.com/office/drawing/2014/main" id="{294777C3-6D2F-4277-840E-7E984FB4554D}"/>
+              </a:ext>
+            </a:extLst>
+          </p:cNvPr>
+          <p:cNvSpPr>
+            <a:spLocks xmlns:a="http://schemas.openxmlformats.org/drawingml/2006/main" noGrp="1"/>
+          </p:cNvSpPr>
+          <p:nvPr/>
+        </p:nvSpPr>
+        <p:spPr>
+          <a:xfrm xmlns:a="http://schemas.openxmlformats.org/drawingml/2006/main">
+            <a:off x="876300" y="2590800"/>
+            <a:ext cx="10553700" cy="9525"/>
+          </a:xfrm>
+          <a:prstGeom xmlns:a="http://schemas.openxmlformats.org/drawingml/2006/main" prst="rect">
+            <a:avLst/>
+          </a:prstGeom>
+          <a:solidFill xmlns:a="http://schemas.openxmlformats.org/drawingml/2006/main">
+            <a:srgbClr val="B8BCC4"/>
+          </a:solidFill>
+          <a:ln xmlns:a="http://schemas.openxmlformats.org/drawingml/2006/main" w="0">
+            <a:solidFill>
+              <a:srgbClr val="B8BCC4"/>
+            </a:solidFill>
+            <a:prstDash val="solid"/>
+          </a:ln>
+        </p:spPr>
+      </p:sp>
+      <p:sp>
+        <p:nvSpPr>
+          <p:cNvPr id="11" name="">
+            <a:extLst xmlns:a="http://schemas.openxmlformats.org/drawingml/2006/main">
+              <a:ext uri="{FF2B5EF4-FFF2-40B4-BE49-F238E27FC236}">
+                <a16:creationId xmlns:a16="http://schemas.microsoft.com/office/drawing/2014/main" id="{F894CF3F-AD63-423C-8F01-64C507896579}"/>
+              </a:ext>
+            </a:extLst>
+          </p:cNvPr>
+          <p:cNvSpPr>
+            <a:spLocks xmlns:a="http://schemas.openxmlformats.org/drawingml/2006/main" noGrp="1"/>
+          </p:cNvSpPr>
+          <p:nvPr/>
+        </p:nvSpPr>
+        <p:spPr>
+          <a:xfrm xmlns:a="http://schemas.openxmlformats.org/drawingml/2006/main">
+            <a:off x="552450" y="2800350"/>
+            <a:ext cx="95250" cy="895350"/>
+          </a:xfrm>
+          <a:prstGeom xmlns:a="http://schemas.openxmlformats.org/drawingml/2006/main" prst="rect">
+            <a:avLst/>
+          </a:prstGeom>
+          <a:solidFill xmlns:a="http://schemas.openxmlformats.org/drawingml/2006/main">
+            <a:srgbClr val="2A9D6F"/>
+          </a:solidFill>
+          <a:ln xmlns:a="http://schemas.openxmlformats.org/drawingml/2006/main" w="0">
+            <a:solidFill>
+              <a:srgbClr val="2A9D6F"/>
+            </a:solidFill>
+            <a:prstDash val="solid"/>
+          </a:ln>
+        </p:spPr>
+      </p:sp>
+      <p:sp>
+        <p:nvSpPr>
+          <p:cNvPr id="12" name="">
+            <a:extLst xmlns:a="http://schemas.openxmlformats.org/drawingml/2006/main">
+              <a:ext uri="{FF2B5EF4-FFF2-40B4-BE49-F238E27FC236}">
+                <a16:creationId xmlns:a16="http://schemas.microsoft.com/office/drawing/2014/main" id="{D3953D03-6A7A-4FEE-B242-02BF0319C169}"/>
+              </a:ext>
+            </a:extLst>
+          </p:cNvPr>
+          <p:cNvSpPr>
+            <a:spLocks xmlns:a="http://schemas.openxmlformats.org/drawingml/2006/main" noGrp="1"/>
+          </p:cNvSpPr>
+          <p:nvPr/>
+        </p:nvSpPr>
+        <p:spPr>
+          <a:xfrm xmlns:a="http://schemas.openxmlformats.org/drawingml/2006/main">
+            <a:off x="876300" y="2781300"/>
+            <a:ext cx="2095500" cy="285750"/>
+          </a:xfrm>
+          <a:prstGeom xmlns:a="http://schemas.openxmlformats.org/drawingml/2006/main" prst="rect">
+            <a:avLst/>
+          </a:prstGeom>
+          <a:noFill xmlns:a="http://schemas.openxmlformats.org/drawingml/2006/main"/>
+          <a:ln xmlns:a="http://schemas.openxmlformats.org/drawingml/2006/main" w="0">
+            <a:noFill/>
+            <a:prstDash val="solid"/>
+          </a:ln>
+        </p:spPr>
+        <p:txBody>
+          <a:bodyPr xmlns:a="http://schemas.openxmlformats.org/drawingml/2006/main" wrap="square" lIns="0" tIns="0" rIns="0" bIns="0" anchor="t">
+            <a:normAutofit fontScale="100000"/>
+          </a:bodyPr>
+          <a:lstStyle xmlns:a="http://schemas.openxmlformats.org/drawingml/2006/main"/>
+          <a:p xmlns:a="http://schemas.openxmlformats.org/drawingml/2006/main">
+            <a:pPr algn="l">
+              <a:buNone/>
+              <a:defRPr sz="1350" b="1">
+                <a:solidFill>
+                  <a:srgbClr val="2A9D6F"/>
+                </a:solidFill>
+                <a:latin typeface="Arial"/>
+                <a:ea typeface="Arial"/>
+                <a:cs typeface="Arial"/>
+              </a:defRPr>
+            </a:pPr>
+            <a:r>
+              <a:rPr sz="1350" b="1">
+                <a:solidFill>
+                  <a:srgbClr val="2A9D6F"/>
+                </a:solidFill>
+                <a:latin typeface="Arial"/>
+                <a:ea typeface="Arial"/>
+                <a:cs typeface="Arial"/>
+              </a:rPr>
+              <a:t>BREADTH</a:t>
+            </a:r>
+          </a:p>
+        </p:txBody>
+      </p:sp>
+      <p:sp>
+        <p:nvSpPr>
+          <p:cNvPr id="13" name="">
+            <a:extLst xmlns:a="http://schemas.openxmlformats.org/drawingml/2006/main">
+              <a:ext uri="{FF2B5EF4-FFF2-40B4-BE49-F238E27FC236}">
+                <a16:creationId xmlns:a16="http://schemas.microsoft.com/office/drawing/2014/main" id="{52D1DBE8-EAF6-4492-89E7-5C97A3A6A395}"/>
+              </a:ext>
+            </a:extLst>
+          </p:cNvPr>
+          <p:cNvSpPr>
+            <a:spLocks xmlns:a="http://schemas.openxmlformats.org/drawingml/2006/main" noGrp="1"/>
+          </p:cNvSpPr>
+          <p:nvPr/>
+        </p:nvSpPr>
+        <p:spPr>
+          <a:xfrm xmlns:a="http://schemas.openxmlformats.org/drawingml/2006/main">
+            <a:off x="3105150" y="2762250"/>
+            <a:ext cx="4762500" cy="419100"/>
+          </a:xfrm>
+          <a:prstGeom xmlns:a="http://schemas.openxmlformats.org/drawingml/2006/main" prst="rect">
+            <a:avLst/>
+          </a:prstGeom>
+          <a:noFill xmlns:a="http://schemas.openxmlformats.org/drawingml/2006/main"/>
+          <a:ln xmlns:a="http://schemas.openxmlformats.org/drawingml/2006/main" w="0">
+            <a:noFill/>
+            <a:prstDash val="solid"/>
+          </a:ln>
+        </p:spPr>
+        <p:txBody>
+          <a:bodyPr xmlns:a="http://schemas.openxmlformats.org/drawingml/2006/main" wrap="square" lIns="0" tIns="0" rIns="0" bIns="0" anchor="t">
+            <a:normAutofit fontScale="100000"/>
+          </a:bodyPr>
+          <a:lstStyle xmlns:a="http://schemas.openxmlformats.org/drawingml/2006/main"/>
+          <a:p xmlns:a="http://schemas.openxmlformats.org/drawingml/2006/main">
+            <a:pPr algn="l">
+              <a:buNone/>
+              <a:defRPr sz="1950" b="1">
+                <a:solidFill>
+                  <a:srgbClr val="273548"/>
+                </a:solidFill>
+                <a:latin typeface="Arial"/>
+                <a:ea typeface="Arial"/>
+                <a:cs typeface="Arial"/>
+              </a:defRPr>
+            </a:pPr>
+            <a:r>
+              <a:rPr sz="1950" b="1">
+                <a:solidFill>
+                  <a:srgbClr val="273548"/>
+                </a:solidFill>
+                <a:latin typeface="Arial"/>
+                <a:ea typeface="Arial"/>
+                <a:cs typeface="Arial"/>
+              </a:rPr>
+              <a:t>All sector medians favor sideways</a:t>
+            </a:r>
+          </a:p>
+        </p:txBody>
+      </p:sp>
+      <p:sp>
+        <p:nvSpPr>
+          <p:cNvPr id="14" name="">
+            <a:extLst xmlns:a="http://schemas.openxmlformats.org/drawingml/2006/main">
+              <a:ext uri="{FF2B5EF4-FFF2-40B4-BE49-F238E27FC236}">
+                <a16:creationId xmlns:a16="http://schemas.microsoft.com/office/drawing/2014/main" id="{2CAF0156-C9E6-4210-8A8A-BFEDD044631B}"/>
+              </a:ext>
+            </a:extLst>
+          </p:cNvPr>
+          <p:cNvSpPr>
+            <a:spLocks xmlns:a="http://schemas.openxmlformats.org/drawingml/2006/main" noGrp="1"/>
+          </p:cNvSpPr>
+          <p:nvPr/>
+        </p:nvSpPr>
+        <p:spPr>
+          <a:xfrm xmlns:a="http://schemas.openxmlformats.org/drawingml/2006/main">
+            <a:off x="8096250" y="2781300"/>
+            <a:ext cx="3333750" cy="704850"/>
+          </a:xfrm>
+          <a:prstGeom xmlns:a="http://schemas.openxmlformats.org/drawingml/2006/main" prst="rect">
+            <a:avLst/>
+          </a:prstGeom>
+          <a:noFill xmlns:a="http://schemas.openxmlformats.org/drawingml/2006/main"/>
+          <a:ln xmlns:a="http://schemas.openxmlformats.org/drawingml/2006/main" w="0">
+            <a:noFill/>
+            <a:prstDash val="solid"/>
+          </a:ln>
+        </p:spPr>
+        <p:txBody>
+          <a:bodyPr xmlns:a="http://schemas.openxmlformats.org/drawingml/2006/main" wrap="square" lIns="0" tIns="0" rIns="0" bIns="0" anchor="t">
+            <a:normAutofit fontScale="100000"/>
+          </a:bodyPr>
+          <a:lstStyle xmlns:a="http://schemas.openxmlformats.org/drawingml/2006/main"/>
+          <a:p xmlns:a="http://schemas.openxmlformats.org/drawingml/2006/main">
+            <a:pPr algn="l">
+              <a:buNone/>
+              <a:defRPr sz="1425" b="0">
+                <a:solidFill>
+                  <a:srgbClr val="667384"/>
+                </a:solidFill>
+                <a:latin typeface="Arial"/>
+                <a:ea typeface="Arial"/>
+                <a:cs typeface="Arial"/>
+              </a:defRPr>
+            </a:pPr>
+            <a:r>
+              <a:rPr sz="1425" b="0">
+                <a:solidFill>
+                  <a:srgbClr val="667384"/>
+                </a:solidFill>
+                <a:latin typeface="Arial"/>
+                <a:ea typeface="Arial"/>
+                <a:cs typeface="Arial"/>
+              </a:rPr>
+              <a:t>62.2%–85.8% positive-cell breadth</a:t>
+            </a:r>
+          </a:p>
+        </p:txBody>
+      </p:sp>
+      <p:sp>
+        <p:nvSpPr>
+          <p:cNvPr id="15" name="">
+            <a:extLst xmlns:a="http://schemas.openxmlformats.org/drawingml/2006/main">
+              <a:ext uri="{FF2B5EF4-FFF2-40B4-BE49-F238E27FC236}">
+                <a16:creationId xmlns:a16="http://schemas.microsoft.com/office/drawing/2014/main" id="{B126165D-5B65-44DB-99BD-15ED33F9B90F}"/>
+              </a:ext>
+            </a:extLst>
+          </p:cNvPr>
+          <p:cNvSpPr>
+            <a:spLocks xmlns:a="http://schemas.openxmlformats.org/drawingml/2006/main" noGrp="1"/>
+          </p:cNvSpPr>
+          <p:nvPr/>
+        </p:nvSpPr>
+        <p:spPr>
+          <a:xfrm xmlns:a="http://schemas.openxmlformats.org/drawingml/2006/main">
+            <a:off x="876300" y="3790950"/>
+            <a:ext cx="10553700" cy="9525"/>
+          </a:xfrm>
+          <a:prstGeom xmlns:a="http://schemas.openxmlformats.org/drawingml/2006/main" prst="rect">
+            <a:avLst/>
+          </a:prstGeom>
+          <a:solidFill xmlns:a="http://schemas.openxmlformats.org/drawingml/2006/main">
+            <a:srgbClr val="B8BCC4"/>
+          </a:solidFill>
+          <a:ln xmlns:a="http://schemas.openxmlformats.org/drawingml/2006/main" w="0">
+            <a:solidFill>
+              <a:srgbClr val="B8BCC4"/>
+            </a:solidFill>
+            <a:prstDash val="solid"/>
+          </a:ln>
+        </p:spPr>
+      </p:sp>
+      <p:sp>
+        <p:nvSpPr>
+          <p:cNvPr id="16" name="">
+            <a:extLst xmlns:a="http://schemas.openxmlformats.org/drawingml/2006/main">
+              <a:ext uri="{FF2B5EF4-FFF2-40B4-BE49-F238E27FC236}">
+                <a16:creationId xmlns:a16="http://schemas.microsoft.com/office/drawing/2014/main" id="{7DC0911F-9587-4B19-84C6-11974DB2A91C}"/>
+              </a:ext>
+            </a:extLst>
+          </p:cNvPr>
+          <p:cNvSpPr>
+            <a:spLocks xmlns:a="http://schemas.openxmlformats.org/drawingml/2006/main" noGrp="1"/>
+          </p:cNvSpPr>
+          <p:nvPr/>
+        </p:nvSpPr>
+        <p:spPr>
+          <a:xfrm xmlns:a="http://schemas.openxmlformats.org/drawingml/2006/main">
+            <a:off x="552450" y="4000500"/>
+            <a:ext cx="95250" cy="895350"/>
+          </a:xfrm>
+          <a:prstGeom xmlns:a="http://schemas.openxmlformats.org/drawingml/2006/main" prst="rect">
+            <a:avLst/>
+          </a:prstGeom>
+          <a:solidFill xmlns:a="http://schemas.openxmlformats.org/drawingml/2006/main">
+            <a:srgbClr val="3D8DFF"/>
+          </a:solidFill>
+          <a:ln xmlns:a="http://schemas.openxmlformats.org/drawingml/2006/main" w="0">
+            <a:solidFill>
+              <a:srgbClr val="3D8DFF"/>
+            </a:solidFill>
+            <a:prstDash val="solid"/>
+          </a:ln>
+        </p:spPr>
+      </p:sp>
+      <p:sp>
+        <p:nvSpPr>
+          <p:cNvPr id="17" name="">
+            <a:extLst xmlns:a="http://schemas.openxmlformats.org/drawingml/2006/main">
+              <a:ext uri="{FF2B5EF4-FFF2-40B4-BE49-F238E27FC236}">
+                <a16:creationId xmlns:a16="http://schemas.microsoft.com/office/drawing/2014/main" id="{DAB53991-F50C-4B95-9F23-DAE86BCEDF3B}"/>
+              </a:ext>
+            </a:extLst>
+          </p:cNvPr>
+          <p:cNvSpPr>
+            <a:spLocks xmlns:a="http://schemas.openxmlformats.org/drawingml/2006/main" noGrp="1"/>
+          </p:cNvSpPr>
+          <p:nvPr/>
+        </p:nvSpPr>
+        <p:spPr>
+          <a:xfrm xmlns:a="http://schemas.openxmlformats.org/drawingml/2006/main">
+            <a:off x="876300" y="3981450"/>
+            <a:ext cx="2095500" cy="285750"/>
+          </a:xfrm>
+          <a:prstGeom xmlns:a="http://schemas.openxmlformats.org/drawingml/2006/main" prst="rect">
+            <a:avLst/>
+          </a:prstGeom>
+          <a:noFill xmlns:a="http://schemas.openxmlformats.org/drawingml/2006/main"/>
+          <a:ln xmlns:a="http://schemas.openxmlformats.org/drawingml/2006/main" w="0">
+            <a:noFill/>
+            <a:prstDash val="solid"/>
+          </a:ln>
+        </p:spPr>
+        <p:txBody>
+          <a:bodyPr xmlns:a="http://schemas.openxmlformats.org/drawingml/2006/main" wrap="square" lIns="0" tIns="0" rIns="0" bIns="0" anchor="t">
+            <a:normAutofit fontScale="100000"/>
+          </a:bodyPr>
+          <a:lstStyle xmlns:a="http://schemas.openxmlformats.org/drawingml/2006/main"/>
+          <a:p xmlns:a="http://schemas.openxmlformats.org/drawingml/2006/main">
+            <a:pPr algn="l">
+              <a:buNone/>
+              <a:defRPr sz="1350" b="1">
+                <a:solidFill>
+                  <a:srgbClr val="3D8DFF"/>
+                </a:solidFill>
+                <a:latin typeface="Arial"/>
+                <a:ea typeface="Arial"/>
+                <a:cs typeface="Arial"/>
+              </a:defRPr>
+            </a:pPr>
+            <a:r>
+              <a:rPr sz="1350" b="1">
+                <a:solidFill>
+                  <a:srgbClr val="3D8DFF"/>
+                </a:solidFill>
+                <a:latin typeface="Arial"/>
+                <a:ea typeface="Arial"/>
+                <a:cs typeface="Arial"/>
+              </a:rPr>
+              <a:t>LIMITS</a:t>
+            </a:r>
+          </a:p>
+        </p:txBody>
+      </p:sp>
+      <p:sp>
+        <p:nvSpPr>
+          <p:cNvPr id="18" name="">
+            <a:extLst xmlns:a="http://schemas.openxmlformats.org/drawingml/2006/main">
+              <a:ext uri="{FF2B5EF4-FFF2-40B4-BE49-F238E27FC236}">
+                <a16:creationId xmlns:a16="http://schemas.microsoft.com/office/drawing/2014/main" id="{5DFACF3B-08BC-4148-A40A-2004DFB81D71}"/>
+              </a:ext>
+            </a:extLst>
+          </p:cNvPr>
+          <p:cNvSpPr>
+            <a:spLocks xmlns:a="http://schemas.openxmlformats.org/drawingml/2006/main" noGrp="1"/>
+          </p:cNvSpPr>
+          <p:nvPr/>
+        </p:nvSpPr>
+        <p:spPr>
+          <a:xfrm xmlns:a="http://schemas.openxmlformats.org/drawingml/2006/main">
+            <a:off x="3105150" y="3962400"/>
+            <a:ext cx="4762500" cy="419100"/>
+          </a:xfrm>
+          <a:prstGeom xmlns:a="http://schemas.openxmlformats.org/drawingml/2006/main" prst="rect">
+            <a:avLst/>
+          </a:prstGeom>
+          <a:noFill xmlns:a="http://schemas.openxmlformats.org/drawingml/2006/main"/>
+          <a:ln xmlns:a="http://schemas.openxmlformats.org/drawingml/2006/main" w="0">
+            <a:noFill/>
+            <a:prstDash val="solid"/>
+          </a:ln>
+        </p:spPr>
+        <p:txBody>
+          <a:bodyPr xmlns:a="http://schemas.openxmlformats.org/drawingml/2006/main" wrap="square" lIns="0" tIns="0" rIns="0" bIns="0" anchor="t">
+            <a:normAutofit fontScale="100000"/>
+          </a:bodyPr>
+          <a:lstStyle xmlns:a="http://schemas.openxmlformats.org/drawingml/2006/main"/>
+          <a:p xmlns:a="http://schemas.openxmlformats.org/drawingml/2006/main">
+            <a:pPr algn="l">
+              <a:buNone/>
+              <a:defRPr sz="1950" b="1">
+                <a:solidFill>
+                  <a:srgbClr val="273548"/>
+                </a:solidFill>
+                <a:latin typeface="Arial"/>
+                <a:ea typeface="Arial"/>
+                <a:cs typeface="Arial"/>
+              </a:defRPr>
+            </a:pPr>
+            <a:r>
+              <a:rPr sz="1950" b="1">
+                <a:solidFill>
+                  <a:srgbClr val="273548"/>
+                </a:solidFill>
+                <a:latin typeface="Arial"/>
+                <a:ea typeface="Arial"/>
+                <a:cs typeface="Arial"/>
+              </a:rPr>
+              <a:t>Sixteen cells break the pattern</a:t>
+            </a:r>
+          </a:p>
+        </p:txBody>
+      </p:sp>
+      <p:sp>
+        <p:nvSpPr>
+          <p:cNvPr id="19" name="">
+            <a:extLst xmlns:a="http://schemas.openxmlformats.org/drawingml/2006/main">
+              <a:ext uri="{FF2B5EF4-FFF2-40B4-BE49-F238E27FC236}">
+                <a16:creationId xmlns:a16="http://schemas.microsoft.com/office/drawing/2014/main" id="{C907D23B-44A2-43C4-9658-4C6E38430BF5}"/>
+              </a:ext>
+            </a:extLst>
+          </p:cNvPr>
+          <p:cNvSpPr>
+            <a:spLocks xmlns:a="http://schemas.openxmlformats.org/drawingml/2006/main" noGrp="1"/>
+          </p:cNvSpPr>
+          <p:nvPr/>
+        </p:nvSpPr>
+        <p:spPr>
+          <a:xfrm xmlns:a="http://schemas.openxmlformats.org/drawingml/2006/main">
+            <a:off x="8096250" y="3981450"/>
+            <a:ext cx="3333750" cy="704850"/>
+          </a:xfrm>
+          <a:prstGeom xmlns:a="http://schemas.openxmlformats.org/drawingml/2006/main" prst="rect">
+            <a:avLst/>
+          </a:prstGeom>
+          <a:noFill xmlns:a="http://schemas.openxmlformats.org/drawingml/2006/main"/>
+          <a:ln xmlns:a="http://schemas.openxmlformats.org/drawingml/2006/main" w="0">
+            <a:noFill/>
+            <a:prstDash val="solid"/>
+          </a:ln>
+        </p:spPr>
+        <p:txBody>
+          <a:bodyPr xmlns:a="http://schemas.openxmlformats.org/drawingml/2006/main" wrap="square" lIns="0" tIns="0" rIns="0" bIns="0" anchor="t">
+            <a:normAutofit fontScale="100000"/>
+          </a:bodyPr>
+          <a:lstStyle xmlns:a="http://schemas.openxmlformats.org/drawingml/2006/main"/>
+          <a:p xmlns:a="http://schemas.openxmlformats.org/drawingml/2006/main">
+            <a:pPr algn="l">
+              <a:buNone/>
+              <a:defRPr sz="1425" b="0">
+                <a:solidFill>
+                  <a:srgbClr val="667384"/>
+                </a:solidFill>
+                <a:latin typeface="Arial"/>
+                <a:ea typeface="Arial"/>
+                <a:cs typeface="Arial"/>
+              </a:defRPr>
+            </a:pPr>
+            <a:r>
+              <a:rPr sz="1425" b="0">
+                <a:solidFill>
+                  <a:srgbClr val="667384"/>
+                </a:solidFill>
+                <a:latin typeface="Arial"/>
+                <a:ea typeface="Arial"/>
+                <a:cs typeface="Arial"/>
+              </a:rPr>
+              <a:t>Micro, prior-20/long-forward, 100→100</a:t>
+            </a:r>
+          </a:p>
+        </p:txBody>
+      </p:sp>
+      <p:sp>
+        <p:nvSpPr>
+          <p:cNvPr id="20" name="">
+            <a:extLst xmlns:a="http://schemas.openxmlformats.org/drawingml/2006/main">
+              <a:ext uri="{FF2B5EF4-FFF2-40B4-BE49-F238E27FC236}">
+                <a16:creationId xmlns:a16="http://schemas.microsoft.com/office/drawing/2014/main" id="{8042DFC4-7E22-47E6-8C53-1E63A8411C3A}"/>
+              </a:ext>
+            </a:extLst>
+          </p:cNvPr>
+          <p:cNvSpPr>
+            <a:spLocks xmlns:a="http://schemas.openxmlformats.org/drawingml/2006/main" noGrp="1"/>
+          </p:cNvSpPr>
+          <p:nvPr/>
+        </p:nvSpPr>
+        <p:spPr>
+          <a:xfrm xmlns:a="http://schemas.openxmlformats.org/drawingml/2006/main">
+            <a:off x="876300" y="4991100"/>
+            <a:ext cx="10553700" cy="9525"/>
+          </a:xfrm>
+          <a:prstGeom xmlns:a="http://schemas.openxmlformats.org/drawingml/2006/main" prst="rect">
+            <a:avLst/>
+          </a:prstGeom>
+          <a:solidFill xmlns:a="http://schemas.openxmlformats.org/drawingml/2006/main">
+            <a:srgbClr val="B8BCC4"/>
+          </a:solidFill>
+          <a:ln xmlns:a="http://schemas.openxmlformats.org/drawingml/2006/main" w="0">
+            <a:solidFill>
+              <a:srgbClr val="B8BCC4"/>
+            </a:solidFill>
+            <a:prstDash val="solid"/>
+          </a:ln>
+        </p:spPr>
+      </p:sp>
+      <p:sp>
+        <p:nvSpPr>
+          <p:cNvPr id="21" name="">
+            <a:extLst xmlns:a="http://schemas.openxmlformats.org/drawingml/2006/main">
+              <a:ext uri="{FF2B5EF4-FFF2-40B4-BE49-F238E27FC236}">
+                <a16:creationId xmlns:a16="http://schemas.microsoft.com/office/drawing/2014/main" id="{F4066D54-676B-4D0F-93B6-2152B57E41AF}"/>
+              </a:ext>
+            </a:extLst>
+          </p:cNvPr>
+          <p:cNvSpPr>
+            <a:spLocks xmlns:a="http://schemas.openxmlformats.org/drawingml/2006/main" noGrp="1"/>
+          </p:cNvSpPr>
+          <p:nvPr/>
+        </p:nvSpPr>
+        <p:spPr>
+          <a:xfrm xmlns:a="http://schemas.openxmlformats.org/drawingml/2006/main">
+            <a:off x="552450" y="5353050"/>
+            <a:ext cx="10877550" cy="781050"/>
+          </a:xfrm>
+          <a:prstGeom xmlns:a="http://schemas.openxmlformats.org/drawingml/2006/main" prst="rect">
+            <a:avLst/>
+          </a:prstGeom>
+          <a:solidFill xmlns:a="http://schemas.openxmlformats.org/drawingml/2006/main">
+            <a:srgbClr val="EAF5FB"/>
+          </a:solidFill>
+          <a:ln xmlns:a="http://schemas.openxmlformats.org/drawingml/2006/main" w="0">
+            <a:solidFill>
+              <a:srgbClr val="EAF5FB"/>
+            </a:solidFill>
+            <a:prstDash val="solid"/>
+          </a:ln>
+        </p:spPr>
+      </p:sp>
+      <p:sp>
+        <p:nvSpPr>
+          <p:cNvPr id="22" name="">
+            <a:extLst xmlns:a="http://schemas.openxmlformats.org/drawingml/2006/main">
+              <a:ext uri="{FF2B5EF4-FFF2-40B4-BE49-F238E27FC236}">
+                <a16:creationId xmlns:a16="http://schemas.microsoft.com/office/drawing/2014/main" id="{6E4C79AE-EB98-4B5B-B3D3-11ED0D4C729B}"/>
+              </a:ext>
+            </a:extLst>
+          </p:cNvPr>
+          <p:cNvSpPr>
+            <a:spLocks xmlns:a="http://schemas.openxmlformats.org/drawingml/2006/main" noGrp="1"/>
+          </p:cNvSpPr>
+          <p:nvPr/>
+        </p:nvSpPr>
+        <p:spPr>
+          <a:xfrm xmlns:a="http://schemas.openxmlformats.org/drawingml/2006/main">
+            <a:off x="781050" y="5524500"/>
+            <a:ext cx="2476500" cy="323850"/>
+          </a:xfrm>
+          <a:prstGeom xmlns:a="http://schemas.openxmlformats.org/drawingml/2006/main" prst="rect">
+            <a:avLst/>
+          </a:prstGeom>
+          <a:noFill xmlns:a="http://schemas.openxmlformats.org/drawingml/2006/main"/>
+          <a:ln xmlns:a="http://schemas.openxmlformats.org/drawingml/2006/main" w="0">
+            <a:noFill/>
+            <a:prstDash val="solid"/>
+          </a:ln>
+        </p:spPr>
+        <p:txBody>
+          <a:bodyPr xmlns:a="http://schemas.openxmlformats.org/drawingml/2006/main" wrap="square" lIns="0" tIns="0" rIns="0" bIns="0" anchor="t">
+            <a:normAutofit fontScale="100000"/>
+          </a:bodyPr>
+          <a:lstStyle xmlns:a="http://schemas.openxmlformats.org/drawingml/2006/main"/>
+          <a:p xmlns:a="http://schemas.openxmlformats.org/drawingml/2006/main">
+            <a:pPr algn="l">
+              <a:buNone/>
+              <a:defRPr sz="1725" b="1">
+                <a:solidFill>
+                  <a:srgbClr val="3D8DFF"/>
+                </a:solidFill>
+                <a:latin typeface="Arial"/>
+                <a:ea typeface="Arial"/>
+                <a:cs typeface="Arial"/>
+              </a:defRPr>
+            </a:pPr>
+            <a:r>
+              <a:rPr sz="1725" b="1">
+                <a:solidFill>
+                  <a:srgbClr val="3D8DFF"/>
+                </a:solidFill>
+                <a:latin typeface="Arial"/>
+                <a:ea typeface="Arial"/>
+                <a:cs typeface="Arial"/>
+              </a:rPr>
+              <a:t>STATUS</a:t>
+            </a:r>
+          </a:p>
+        </p:txBody>
+      </p:sp>
+      <p:sp>
+        <p:nvSpPr>
+          <p:cNvPr id="23" name="">
+            <a:extLst xmlns:a="http://schemas.openxmlformats.org/drawingml/2006/main">
+              <a:ext uri="{FF2B5EF4-FFF2-40B4-BE49-F238E27FC236}">
+                <a16:creationId xmlns:a16="http://schemas.microsoft.com/office/drawing/2014/main" id="{3320D60E-6067-4236-80ED-A898A863026E}"/>
+              </a:ext>
+            </a:extLst>
+          </p:cNvPr>
+          <p:cNvSpPr>
+            <a:spLocks xmlns:a="http://schemas.openxmlformats.org/drawingml/2006/main" noGrp="1"/>
+          </p:cNvSpPr>
+          <p:nvPr/>
+        </p:nvSpPr>
+        <p:spPr>
+          <a:xfrm xmlns:a="http://schemas.openxmlformats.org/drawingml/2006/main">
+            <a:off x="3333750" y="5486400"/>
+            <a:ext cx="7810500" cy="419100"/>
+          </a:xfrm>
+          <a:prstGeom xmlns:a="http://schemas.openxmlformats.org/drawingml/2006/main" prst="rect">
+            <a:avLst/>
+          </a:prstGeom>
+          <a:noFill xmlns:a="http://schemas.openxmlformats.org/drawingml/2006/main"/>
+          <a:ln xmlns:a="http://schemas.openxmlformats.org/drawingml/2006/main" w="0">
+            <a:noFill/>
+            <a:prstDash val="solid"/>
+          </a:ln>
+        </p:spPr>
+        <p:txBody>
+          <a:bodyPr xmlns:a="http://schemas.openxmlformats.org/drawingml/2006/main" wrap="square" lIns="0" tIns="0" rIns="0" bIns="0" anchor="t">
+            <a:normAutofit fontScale="76389"/>
+          </a:bodyPr>
+          <a:lstStyle xmlns:a="http://schemas.openxmlformats.org/drawingml/2006/main"/>
+          <a:p xmlns:a="http://schemas.openxmlformats.org/drawingml/2006/main">
+            <a:pPr algn="l">
+              <a:buNone/>
+              <a:defRPr sz="1800" b="1">
+                <a:solidFill>
+                  <a:srgbClr val="273548"/>
+                </a:solidFill>
+                <a:latin typeface="Arial"/>
+                <a:ea typeface="Arial"/>
+                <a:cs typeface="Arial"/>
+              </a:defRPr>
+            </a:pPr>
+            <a:r>
+              <a:rPr sz="1800" b="1">
+                <a:solidFill>
+                  <a:srgbClr val="273548"/>
+                </a:solidFill>
+                <a:latin typeface="Arial"/>
+                <a:ea typeface="Arial"/>
+                <a:cs typeface="Arial"/>
+              </a:rPr>
+              <a:t>BEHAV-MOM-01 remains a behavioral lead. Do not select a horizon or open a next-open rule, baseline, or post-2023 confirmation yet.</a:t>
+            </a:r>
+          </a:p>
+        </p:txBody>
+      </p:sp>
+    </p:spTree>
+    <p:extLst>
+      <p:ext uri="{BB962C8B-B14F-4D97-AF65-F5344CB8AC3E}">
+        <p14:creationId xmlns:p14="http://schemas.microsoft.com/office/powerpoint/2010/main" val="666536286"/>
+      </p:ext>
+    </p:extLst>
+  </p:cSld>
+</p:sld>
+</file>
+
 <file path=ppt/slides/slide2.xml><?xml version="1.0" encoding="utf-8"?>
 <p:sld xmlns:p="http://schemas.openxmlformats.org/presentationml/2006/main">
   <p:cSld>
@@ -3443,7 +6799,7 @@
         </p:spPr>
         <p:txBody>
           <a:bodyPr xmlns:a="http://schemas.openxmlformats.org/drawingml/2006/main" wrap="square" lIns="0" tIns="0" rIns="0" bIns="0" anchor="t">
-            <a:normAutofit fontScale="87656"/>
+            <a:normAutofit fontScale="100000"/>
           </a:bodyPr>
           <a:lstStyle xmlns:a="http://schemas.openxmlformats.org/drawingml/2006/main"/>
           <a:p xmlns:a="http://schemas.openxmlformats.org/drawingml/2006/main">
@@ -3467,7 +6823,7 @@
                 <a:ea typeface="Arial"/>
                 <a:cs typeface="Arial"/>
               </a:rPr>
-              <a:t>Aggregation reveals a weak 5–10-session continuation ridge</a:t>
+              <a:t>A weak 5–10-session continuation ridge appears</a:t>
             </a:r>
           </a:p>
         </p:txBody>
@@ -3632,7 +6988,7 @@
           <p:nvPr/>
         </p:nvPicPr>
         <p:blipFill>
-          <a:blip xmlns:r="http://schemas.openxmlformats.org/officeDocument/2006/relationships" xmlns:a="http://schemas.openxmlformats.org/drawingml/2006/main" r:embed="R38e442798bd64490"/>
+          <a:blip xmlns:r="http://schemas.openxmlformats.org/officeDocument/2006/relationships" xmlns:a="http://schemas.openxmlformats.org/drawingml/2006/main" r:embed="R59d79921c91f4537"/>
           <a:stretch xmlns:a="http://schemas.openxmlformats.org/drawingml/2006/main"/>
         </p:blipFill>
         <p:spPr>
@@ -3952,7 +7308,7 @@
           <p:nvPr/>
         </p:nvPicPr>
         <p:blipFill>
-          <a:blip xmlns:r="http://schemas.openxmlformats.org/officeDocument/2006/relationships" xmlns:a="http://schemas.openxmlformats.org/drawingml/2006/main" r:embed="Rc2a9f2b61768460a"/>
+          <a:blip xmlns:r="http://schemas.openxmlformats.org/officeDocument/2006/relationships" xmlns:a="http://schemas.openxmlformats.org/drawingml/2006/main" r:embed="R662083d1f331452a"/>
           <a:stretch xmlns:a="http://schemas.openxmlformats.org/drawingml/2006/main"/>
         </p:blipFill>
         <p:spPr>
@@ -4272,7 +7628,7 @@
           <p:nvPr/>
         </p:nvPicPr>
         <p:blipFill>
-          <a:blip xmlns:r="http://schemas.openxmlformats.org/officeDocument/2006/relationships" xmlns:a="http://schemas.openxmlformats.org/drawingml/2006/main" r:embed="Rf909af196ba2469d"/>
+          <a:blip xmlns:r="http://schemas.openxmlformats.org/officeDocument/2006/relationships" xmlns:a="http://schemas.openxmlformats.org/drawingml/2006/main" r:embed="R34f12cb8d38c4bb2"/>
           <a:stretch xmlns:a="http://schemas.openxmlformats.org/drawingml/2006/main"/>
         </p:blipFill>
         <p:spPr>
@@ -4403,7 +7759,7 @@
         </p:spPr>
         <p:txBody>
           <a:bodyPr xmlns:a="http://schemas.openxmlformats.org/drawingml/2006/main" wrap="square" lIns="0" tIns="0" rIns="0" bIns="0" anchor="t">
-            <a:normAutofit fontScale="87656"/>
+            <a:normAutofit fontScale="99137"/>
           </a:bodyPr>
           <a:lstStyle xmlns:a="http://schemas.openxmlformats.org/drawingml/2006/main"/>
           <a:p xmlns:a="http://schemas.openxmlformats.org/drawingml/2006/main">
@@ -4427,7 +7783,7 @@
                 <a:ea typeface="Arial"/>
                 <a:cs typeface="Arial"/>
               </a:rPr>
-              <a:t>Sideways paths carry the atlas's largest continuation cluster</a:t>
+              <a:t>Sideways paths carry the largest continuation cluster</a:t>
             </a:r>
           </a:p>
         </p:txBody>
@@ -4592,7 +7948,7 @@
           <p:nvPr/>
         </p:nvPicPr>
         <p:blipFill>
-          <a:blip xmlns:r="http://schemas.openxmlformats.org/officeDocument/2006/relationships" xmlns:a="http://schemas.openxmlformats.org/drawingml/2006/main" r:embed="Rc41909ef7da04c63"/>
+          <a:blip xmlns:r="http://schemas.openxmlformats.org/officeDocument/2006/relationships" xmlns:a="http://schemas.openxmlformats.org/drawingml/2006/main" r:embed="R3bfd2aef541446b8"/>
           <a:stretch xmlns:a="http://schemas.openxmlformats.org/drawingml/2006/main"/>
         </p:blipFill>
         <p:spPr>
@@ -4912,7 +8268,7 @@
           <p:nvPr/>
         </p:nvPicPr>
         <p:blipFill>
-          <a:blip xmlns:r="http://schemas.openxmlformats.org/officeDocument/2006/relationships" xmlns:a="http://schemas.openxmlformats.org/drawingml/2006/main" r:embed="R62bcabc3f2b040eb"/>
+          <a:blip xmlns:r="http://schemas.openxmlformats.org/officeDocument/2006/relationships" xmlns:a="http://schemas.openxmlformats.org/drawingml/2006/main" r:embed="Rdf95817faae04f76"/>
           <a:stretch xmlns:a="http://schemas.openxmlformats.org/drawingml/2006/main"/>
         </p:blipFill>
         <p:spPr>

</xml_diff>